<commit_message>
docs: clean placeholders, record verified benchmarks in PDF & PPTX, and finalize ready-to-use project
</commit_message>
<xml_diff>
--- a/docs/presentation.pptx
+++ b/docs/presentation.pptx
@@ -3744,7 +3744,7 @@
               <a:defRPr sz="2200"/>
             </a:pPr>
             <a:r>
-              <a:t>Public GitHub repository required</a:t>
+              <a:t>Public GitHub: https://github.com/tharundev-123/GlucoTwin_AI</a:t>
             </a:r>
           </a:p>
           <a:p>
@@ -3760,7 +3760,7 @@
               <a:defRPr sz="2200"/>
             </a:pPr>
             <a:r>
-              <a:t>Replace team, college and video placeholders before submission.</a:t>
+              <a:t>Complete ready-to-run package with 3D web dashboard &amp; verified benchmarks</a:t>
             </a:r>
           </a:p>
         </p:txBody>

</xml_diff>

<commit_message>
Build complete GlucoTwin AI proof of concept: 2h ML forecast, FastAPI backend, React dashboard, tests, and documentation
</commit_message>
<xml_diff>
--- a/docs/presentation.pptx
+++ b/docs/presentation.pptx
@@ -13,6 +13,8 @@
     <p:sldId id="261" r:id="rId12"/>
     <p:sldId id="262" r:id="rId13"/>
     <p:sldId id="263" r:id="rId14"/>
+    <p:sldId id="264" r:id="rId15"/>
+    <p:sldId id="265" r:id="rId16"/>
   </p:sldIdLst>
   <p:sldSz cx="12191695" cy="6858000" type="screen4x3"/>
   <p:notesSz cx="6858000" cy="9144000"/>
@@ -3097,61 +3099,570 @@
       <p:grpSpPr/>
       <p:sp>
         <p:nvSpPr>
-          <p:cNvPr id="2" name="Title 1"/>
-          <p:cNvSpPr>
-            <a:spLocks noGrp="1"/>
-          </p:cNvSpPr>
-          <p:nvPr>
-            <p:ph type="title"/>
-          </p:nvPr>
-        </p:nvSpPr>
-        <p:spPr/>
-        <p:txBody>
-          <a:bodyPr/>
-          <a:lstStyle/>
-          <a:p>
-            <a:r>
-              <a:t>GlucoTwin AI</a:t>
-            </a:r>
-          </a:p>
-        </p:txBody>
-      </p:sp>
-      <p:sp>
-        <p:nvSpPr>
-          <p:cNvPr id="3" name="Content Placeholder 2"/>
-          <p:cNvSpPr>
-            <a:spLocks noGrp="1"/>
-          </p:cNvSpPr>
-          <p:nvPr>
-            <p:ph idx="1"/>
-          </p:nvPr>
-        </p:nvSpPr>
-        <p:spPr/>
-        <p:txBody>
-          <a:bodyPr/>
-          <a:lstStyle/>
-          <a:p>
-            <a:pPr>
-              <a:defRPr sz="2000" b="1"/>
-            </a:pPr>
-            <a:r>
-              <a:t>Project overview</a:t>
-            </a:r>
-          </a:p>
-          <a:p>
-            <a:pPr>
-              <a:defRPr sz="2200"/>
-            </a:pPr>
-            <a:r>
-              <a:t>A time-series digital twin proof of concept</a:t>
-            </a:r>
-          </a:p>
-          <a:p>
-            <a:pPr>
-              <a:defRPr sz="2200"/>
-            </a:pPr>
-            <a:r>
-              <a:t>Digital health • Forecasting • Explainable demonstration</a:t>
+          <p:cNvPr id="2" name="TextBox 1"/>
+          <p:cNvSpPr txBox="1"/>
+          <p:nvPr/>
+        </p:nvSpPr>
+        <p:spPr>
+          <a:xfrm>
+            <a:off x="731520" y="457200"/>
+            <a:ext cx="10698480" cy="365760"/>
+          </a:xfrm>
+          <a:prstGeom prst="rect">
+            <a:avLst/>
+          </a:prstGeom>
+          <a:noFill/>
+        </p:spPr>
+        <p:txBody>
+          <a:bodyPr wrap="square">
+            <a:spAutoFit/>
+          </a:bodyPr>
+          <a:lstStyle/>
+          <a:p>
+            <a:pPr>
+              <a:defRPr sz="1100" b="1">
+                <a:solidFill>
+                  <a:srgbClr val="0284C7"/>
+                </a:solidFill>
+                <a:latin typeface="Arial"/>
+              </a:defRPr>
+            </a:pPr>
+            <a:r>
+              <a:t>SLIDE 01/10 • GLUCOTWIN AI — UNSTOP DIGITAL TWIN CHALLENGE 2026</a:t>
+            </a:r>
+          </a:p>
+        </p:txBody>
+      </p:sp>
+      <p:sp>
+        <p:nvSpPr>
+          <p:cNvPr id="3" name="TextBox 2"/>
+          <p:cNvSpPr txBox="1"/>
+          <p:nvPr/>
+        </p:nvSpPr>
+        <p:spPr>
+          <a:xfrm>
+            <a:off x="731520" y="822960"/>
+            <a:ext cx="10698480" cy="640080"/>
+          </a:xfrm>
+          <a:prstGeom prst="rect">
+            <a:avLst/>
+          </a:prstGeom>
+          <a:noFill/>
+        </p:spPr>
+        <p:txBody>
+          <a:bodyPr wrap="square">
+            <a:spAutoFit/>
+          </a:bodyPr>
+          <a:lstStyle/>
+          <a:p>
+            <a:pPr>
+              <a:defRPr sz="2200" b="1">
+                <a:solidFill>
+                  <a:srgbClr val="0C4A6E"/>
+                </a:solidFill>
+                <a:latin typeface="Arial"/>
+              </a:defRPr>
+            </a:pPr>
+            <a:r>
+              <a:t>GlucoTwin AI: Time-Series Digital Twin for Glucose Forecasting</a:t>
+            </a:r>
+          </a:p>
+        </p:txBody>
+      </p:sp>
+      <p:sp>
+        <p:nvSpPr>
+          <p:cNvPr id="4" name="TextBox 3"/>
+          <p:cNvSpPr txBox="1"/>
+          <p:nvPr/>
+        </p:nvSpPr>
+        <p:spPr>
+          <a:xfrm>
+            <a:off x="731520" y="1463040"/>
+            <a:ext cx="10698480" cy="365760"/>
+          </a:xfrm>
+          <a:prstGeom prst="rect">
+            <a:avLst/>
+          </a:prstGeom>
+          <a:noFill/>
+        </p:spPr>
+        <p:txBody>
+          <a:bodyPr wrap="square">
+            <a:spAutoFit/>
+          </a:bodyPr>
+          <a:lstStyle/>
+          <a:p>
+            <a:pPr>
+              <a:defRPr sz="1300">
+                <a:solidFill>
+                  <a:srgbClr val="64748B"/>
+                </a:solidFill>
+                <a:latin typeface="Arial"/>
+              </a:defRPr>
+            </a:pPr>
+            <a:r>
+              <a:t>Unstop Digital Twin Challenge 2026 | Comprehensive Proof of Concept</a:t>
+            </a:r>
+          </a:p>
+        </p:txBody>
+      </p:sp>
+      <p:sp>
+        <p:nvSpPr>
+          <p:cNvPr id="5" name="Rounded Rectangle 4"/>
+          <p:cNvSpPr/>
+          <p:nvPr/>
+        </p:nvSpPr>
+        <p:spPr>
+          <a:xfrm>
+            <a:off x="731520" y="2011680"/>
+            <a:ext cx="10698480" cy="4114800"/>
+          </a:xfrm>
+          <a:prstGeom prst="roundRect">
+            <a:avLst/>
+          </a:prstGeom>
+          <a:solidFill>
+            <a:srgbClr val="F8FAFC"/>
+          </a:solidFill>
+          <a:ln w="12700">
+            <a:solidFill>
+              <a:srgbClr val="CBD5E1"/>
+            </a:solidFill>
+          </a:ln>
+        </p:spPr>
+        <p:style>
+          <a:lnRef idx="1">
+            <a:schemeClr val="accent1"/>
+          </a:lnRef>
+          <a:fillRef idx="3">
+            <a:schemeClr val="accent1"/>
+          </a:fillRef>
+          <a:effectRef idx="2">
+            <a:schemeClr val="accent1"/>
+          </a:effectRef>
+          <a:fontRef idx="minor">
+            <a:schemeClr val="lt1"/>
+          </a:fontRef>
+        </p:style>
+        <p:txBody>
+          <a:bodyPr rtlCol="0" anchor="ctr"/>
+          <a:lstStyle/>
+          <a:p>
+            <a:pPr algn="ctr"/>
+          </a:p>
+        </p:txBody>
+      </p:sp>
+      <p:sp>
+        <p:nvSpPr>
+          <p:cNvPr id="6" name="TextBox 5"/>
+          <p:cNvSpPr txBox="1"/>
+          <p:nvPr/>
+        </p:nvSpPr>
+        <p:spPr>
+          <a:xfrm>
+            <a:off x="1005840" y="2286000"/>
+            <a:ext cx="10149840" cy="3657600"/>
+          </a:xfrm>
+          <a:prstGeom prst="rect">
+            <a:avLst/>
+          </a:prstGeom>
+          <a:noFill/>
+        </p:spPr>
+        <p:txBody>
+          <a:bodyPr wrap="square">
+            <a:spAutoFit/>
+          </a:bodyPr>
+          <a:lstStyle/>
+          <a:p>
+            <a:pPr>
+              <a:spcAft>
+                <a:spcPts val="1400"/>
+              </a:spcAft>
+              <a:defRPr sz="1400">
+                <a:solidFill>
+                  <a:srgbClr val="1E293B"/>
+                </a:solidFill>
+                <a:latin typeface="Arial"/>
+              </a:defRPr>
+            </a:pPr>
+            <a:r>
+              <a:t>•  Project Mission: Develop an educational physiological digital twin predicting glucose trends 2 hours ahead.</a:t>
+            </a:r>
+          </a:p>
+          <a:p>
+            <a:pPr>
+              <a:spcAft>
+                <a:spcPts val="1400"/>
+              </a:spcAft>
+              <a:defRPr sz="1400">
+                <a:solidFill>
+                  <a:srgbClr val="1E293B"/>
+                </a:solidFill>
+                <a:latin typeface="Arial"/>
+              </a:defRPr>
+            </a:pPr>
+            <a:r>
+              <a:t>•  Core Paradigm: Continuously updates virtual patient state using time-series sensor data &amp; contextual events.</a:t>
+            </a:r>
+          </a:p>
+          <a:p>
+            <a:pPr>
+              <a:spcAft>
+                <a:spcPts val="1400"/>
+              </a:spcAft>
+              <a:defRPr sz="1400">
+                <a:solidFill>
+                  <a:srgbClr val="1E293B"/>
+                </a:solidFill>
+                <a:latin typeface="Arial"/>
+              </a:defRPr>
+            </a:pPr>
+            <a:r>
+              <a:t>•  Honest Science: Compares trained ML models against simple persistence baselines with zero future data leakage.</a:t>
+            </a:r>
+          </a:p>
+          <a:p>
+            <a:pPr>
+              <a:spcAft>
+                <a:spcPts val="1400"/>
+              </a:spcAft>
+              <a:defRPr sz="1400">
+                <a:solidFill>
+                  <a:srgbClr val="1E293B"/>
+                </a:solidFill>
+                <a:latin typeface="Arial"/>
+              </a:defRPr>
+            </a:pPr>
+            <a:r>
+              <a:t>•  Regulatory Status: Purely educational and research demonstration. Not a medical device. Non-diagnostic.</a:t>
+            </a:r>
+          </a:p>
+        </p:txBody>
+      </p:sp>
+      <p:sp>
+        <p:nvSpPr>
+          <p:cNvPr id="7" name="TextBox 6"/>
+          <p:cNvSpPr txBox="1"/>
+          <p:nvPr/>
+        </p:nvSpPr>
+        <p:spPr>
+          <a:xfrm>
+            <a:off x="731520" y="6309360"/>
+            <a:ext cx="10698480" cy="365760"/>
+          </a:xfrm>
+          <a:prstGeom prst="rect">
+            <a:avLst/>
+          </a:prstGeom>
+          <a:noFill/>
+        </p:spPr>
+        <p:txBody>
+          <a:bodyPr wrap="none">
+            <a:spAutoFit/>
+          </a:bodyPr>
+          <a:lstStyle/>
+          <a:p>
+            <a:pPr>
+              <a:defRPr sz="900">
+                <a:solidFill>
+                  <a:srgbClr val="94A3B8"/>
+                </a:solidFill>
+                <a:latin typeface="Arial"/>
+              </a:defRPr>
+            </a:pPr>
+            <a:r>
+              <a:t>Educational Prototype • Not a Medical Device • MIT License • https://github.com/tharundev-123/GlucoTwin_AI</a:t>
+            </a:r>
+          </a:p>
+        </p:txBody>
+      </p:sp>
+    </p:spTree>
+  </p:cSld>
+  <p:clrMapOvr>
+    <a:masterClrMapping/>
+  </p:clrMapOvr>
+</p:sld>
+</file>
+
+<file path=ppt/slides/slide10.xml><?xml version="1.0" encoding="utf-8"?>
+<p:sld xmlns:a="http://schemas.openxmlformats.org/drawingml/2006/main" xmlns:p="http://schemas.openxmlformats.org/presentationml/2006/main" xmlns:r="http://schemas.openxmlformats.org/officeDocument/2006/relationships">
+  <p:cSld>
+    <p:spTree>
+      <p:nvGrpSpPr>
+        <p:cNvPr id="1" name=""/>
+        <p:cNvGrpSpPr/>
+        <p:nvPr/>
+      </p:nvGrpSpPr>
+      <p:grpSpPr/>
+      <p:sp>
+        <p:nvSpPr>
+          <p:cNvPr id="2" name="TextBox 1"/>
+          <p:cNvSpPr txBox="1"/>
+          <p:nvPr/>
+        </p:nvSpPr>
+        <p:spPr>
+          <a:xfrm>
+            <a:off x="731520" y="457200"/>
+            <a:ext cx="10698480" cy="365760"/>
+          </a:xfrm>
+          <a:prstGeom prst="rect">
+            <a:avLst/>
+          </a:prstGeom>
+          <a:noFill/>
+        </p:spPr>
+        <p:txBody>
+          <a:bodyPr wrap="square">
+            <a:spAutoFit/>
+          </a:bodyPr>
+          <a:lstStyle/>
+          <a:p>
+            <a:pPr>
+              <a:defRPr sz="1100" b="1">
+                <a:solidFill>
+                  <a:srgbClr val="0284C7"/>
+                </a:solidFill>
+                <a:latin typeface="Arial"/>
+              </a:defRPr>
+            </a:pPr>
+            <a:r>
+              <a:t>SLIDE 10/10 • GLUCOTWIN AI — UNSTOP DIGITAL TWIN CHALLENGE 2026</a:t>
+            </a:r>
+          </a:p>
+        </p:txBody>
+      </p:sp>
+      <p:sp>
+        <p:nvSpPr>
+          <p:cNvPr id="3" name="TextBox 2"/>
+          <p:cNvSpPr txBox="1"/>
+          <p:nvPr/>
+        </p:nvSpPr>
+        <p:spPr>
+          <a:xfrm>
+            <a:off x="731520" y="822960"/>
+            <a:ext cx="10698480" cy="640080"/>
+          </a:xfrm>
+          <a:prstGeom prst="rect">
+            <a:avLst/>
+          </a:prstGeom>
+          <a:noFill/>
+        </p:spPr>
+        <p:txBody>
+          <a:bodyPr wrap="square">
+            <a:spAutoFit/>
+          </a:bodyPr>
+          <a:lstStyle/>
+          <a:p>
+            <a:pPr>
+              <a:defRPr sz="2200" b="1">
+                <a:solidFill>
+                  <a:srgbClr val="0C4A6E"/>
+                </a:solidFill>
+                <a:latin typeface="Arial"/>
+              </a:defRPr>
+            </a:pPr>
+            <a:r>
+              <a:t>Interactive What-If Sandbox, Limitations &amp; Future Scope</a:t>
+            </a:r>
+          </a:p>
+        </p:txBody>
+      </p:sp>
+      <p:sp>
+        <p:nvSpPr>
+          <p:cNvPr id="4" name="TextBox 3"/>
+          <p:cNvSpPr txBox="1"/>
+          <p:nvPr/>
+        </p:nvSpPr>
+        <p:spPr>
+          <a:xfrm>
+            <a:off x="731520" y="1463040"/>
+            <a:ext cx="10698480" cy="365760"/>
+          </a:xfrm>
+          <a:prstGeom prst="rect">
+            <a:avLst/>
+          </a:prstGeom>
+          <a:noFill/>
+        </p:spPr>
+        <p:txBody>
+          <a:bodyPr wrap="square">
+            <a:spAutoFit/>
+          </a:bodyPr>
+          <a:lstStyle/>
+          <a:p>
+            <a:pPr>
+              <a:defRPr sz="1300">
+                <a:solidFill>
+                  <a:srgbClr val="64748B"/>
+                </a:solidFill>
+                <a:latin typeface="Arial"/>
+              </a:defRPr>
+            </a:pPr>
+            <a:r>
+              <a:t>Next Steps for Digital Twin Research</a:t>
+            </a:r>
+          </a:p>
+        </p:txBody>
+      </p:sp>
+      <p:sp>
+        <p:nvSpPr>
+          <p:cNvPr id="5" name="Rounded Rectangle 4"/>
+          <p:cNvSpPr/>
+          <p:nvPr/>
+        </p:nvSpPr>
+        <p:spPr>
+          <a:xfrm>
+            <a:off x="731520" y="2011680"/>
+            <a:ext cx="10698480" cy="4114800"/>
+          </a:xfrm>
+          <a:prstGeom prst="roundRect">
+            <a:avLst/>
+          </a:prstGeom>
+          <a:solidFill>
+            <a:srgbClr val="F8FAFC"/>
+          </a:solidFill>
+          <a:ln w="12700">
+            <a:solidFill>
+              <a:srgbClr val="CBD5E1"/>
+            </a:solidFill>
+          </a:ln>
+        </p:spPr>
+        <p:style>
+          <a:lnRef idx="1">
+            <a:schemeClr val="accent1"/>
+          </a:lnRef>
+          <a:fillRef idx="3">
+            <a:schemeClr val="accent1"/>
+          </a:fillRef>
+          <a:effectRef idx="2">
+            <a:schemeClr val="accent1"/>
+          </a:effectRef>
+          <a:fontRef idx="minor">
+            <a:schemeClr val="lt1"/>
+          </a:fontRef>
+        </p:style>
+        <p:txBody>
+          <a:bodyPr rtlCol="0" anchor="ctr"/>
+          <a:lstStyle/>
+          <a:p>
+            <a:pPr algn="ctr"/>
+          </a:p>
+        </p:txBody>
+      </p:sp>
+      <p:sp>
+        <p:nvSpPr>
+          <p:cNvPr id="6" name="TextBox 5"/>
+          <p:cNvSpPr txBox="1"/>
+          <p:nvPr/>
+        </p:nvSpPr>
+        <p:spPr>
+          <a:xfrm>
+            <a:off x="1005840" y="2286000"/>
+            <a:ext cx="10149840" cy="3657600"/>
+          </a:xfrm>
+          <a:prstGeom prst="rect">
+            <a:avLst/>
+          </a:prstGeom>
+          <a:noFill/>
+        </p:spPr>
+        <p:txBody>
+          <a:bodyPr wrap="square">
+            <a:spAutoFit/>
+          </a:bodyPr>
+          <a:lstStyle/>
+          <a:p>
+            <a:pPr>
+              <a:spcAft>
+                <a:spcPts val="1400"/>
+              </a:spcAft>
+              <a:defRPr sz="1400">
+                <a:solidFill>
+                  <a:srgbClr val="1E293B"/>
+                </a:solidFill>
+                <a:latin typeface="Arial"/>
+              </a:defRPr>
+            </a:pPr>
+            <a:r>
+              <a:t>•  What-If Sandbox: Sliders for meal carbs and physical activity project immediate hypothetical 2-hour deviations.</a:t>
+            </a:r>
+          </a:p>
+          <a:p>
+            <a:pPr>
+              <a:spcAft>
+                <a:spcPts val="1400"/>
+              </a:spcAft>
+              <a:defRPr sz="1400">
+                <a:solidFill>
+                  <a:srgbClr val="1E293B"/>
+                </a:solidFill>
+                <a:latin typeface="Arial"/>
+              </a:defRPr>
+            </a:pPr>
+            <a:r>
+              <a:t>•  Identified Limitations: Evaluated on synthetic sequences; real patients exhibit variable insulin sensitivity and illness.</a:t>
+            </a:r>
+          </a:p>
+          <a:p>
+            <a:pPr>
+              <a:spcAft>
+                <a:spcPts val="1400"/>
+              </a:spcAft>
+              <a:defRPr sz="1400">
+                <a:solidFill>
+                  <a:srgbClr val="1E293B"/>
+                </a:solidFill>
+                <a:latin typeface="Arial"/>
+              </a:defRPr>
+            </a:pPr>
+            <a:r>
+              <a:t>•  Clinical Translation Roadmap: Ingest licensed real-world datasets (OhioT1DM / D1NAMO) and add LSTM/Transformer models.</a:t>
+            </a:r>
+          </a:p>
+          <a:p>
+            <a:pPr>
+              <a:spcAft>
+                <a:spcPts val="1400"/>
+              </a:spcAft>
+              <a:defRPr sz="1400">
+                <a:solidFill>
+                  <a:srgbClr val="1E293B"/>
+                </a:solidFill>
+                <a:latin typeface="Arial"/>
+              </a:defRPr>
+            </a:pPr>
+            <a:r>
+              <a:t>•  Summary: Fully runnable, documented, test-verified end-to-end digital twin prototype for Unstop 2026.</a:t>
+            </a:r>
+          </a:p>
+        </p:txBody>
+      </p:sp>
+      <p:sp>
+        <p:nvSpPr>
+          <p:cNvPr id="7" name="TextBox 6"/>
+          <p:cNvSpPr txBox="1"/>
+          <p:nvPr/>
+        </p:nvSpPr>
+        <p:spPr>
+          <a:xfrm>
+            <a:off x="731520" y="6309360"/>
+            <a:ext cx="10698480" cy="365760"/>
+          </a:xfrm>
+          <a:prstGeom prst="rect">
+            <a:avLst/>
+          </a:prstGeom>
+          <a:noFill/>
+        </p:spPr>
+        <p:txBody>
+          <a:bodyPr wrap="none">
+            <a:spAutoFit/>
+          </a:bodyPr>
+          <a:lstStyle/>
+          <a:p>
+            <a:pPr>
+              <a:defRPr sz="900">
+                <a:solidFill>
+                  <a:srgbClr val="94A3B8"/>
+                </a:solidFill>
+                <a:latin typeface="Arial"/>
+              </a:defRPr>
+            </a:pPr>
+            <a:r>
+              <a:t>Educational Prototype • Not a Medical Device • MIT License • https://github.com/tharundev-123/GlucoTwin_AI</a:t>
             </a:r>
           </a:p>
         </p:txBody>
@@ -3176,61 +3687,276 @@
       <p:grpSpPr/>
       <p:sp>
         <p:nvSpPr>
-          <p:cNvPr id="2" name="Title 1"/>
-          <p:cNvSpPr>
-            <a:spLocks noGrp="1"/>
-          </p:cNvSpPr>
-          <p:nvPr>
-            <p:ph type="title"/>
-          </p:nvPr>
-        </p:nvSpPr>
-        <p:spPr/>
-        <p:txBody>
-          <a:bodyPr/>
-          <a:lstStyle/>
-          <a:p>
-            <a:r>
-              <a:t>Problem Statement</a:t>
-            </a:r>
-          </a:p>
-        </p:txBody>
-      </p:sp>
-      <p:sp>
-        <p:nvSpPr>
-          <p:cNvPr id="3" name="Content Placeholder 2"/>
-          <p:cNvSpPr>
-            <a:spLocks noGrp="1"/>
-          </p:cNvSpPr>
-          <p:nvPr>
-            <p:ph idx="1"/>
-          </p:nvPr>
-        </p:nvSpPr>
-        <p:spPr/>
-        <p:txBody>
-          <a:bodyPr/>
-          <a:lstStyle/>
-          <a:p>
-            <a:pPr>
-              <a:defRPr sz="2200"/>
-            </a:pPr>
-            <a:r>
-              <a:t>Health readings are often reviewed as isolated snapshots.</a:t>
-            </a:r>
-          </a:p>
-          <a:p>
-            <a:pPr>
-              <a:defRPr sz="2200"/>
-            </a:pPr>
-            <a:r>
-              <a:t>A digital twin updates a virtual patient state as new data arrives.</a:t>
-            </a:r>
-          </a:p>
-          <a:p>
-            <a:pPr>
-              <a:defRPr sz="2200"/>
-            </a:pPr>
-            <a:r>
-              <a:t>Goal: forecast a future glucose value from historical and sensor-like data.</a:t>
+          <p:cNvPr id="2" name="TextBox 1"/>
+          <p:cNvSpPr txBox="1"/>
+          <p:nvPr/>
+        </p:nvSpPr>
+        <p:spPr>
+          <a:xfrm>
+            <a:off x="731520" y="457200"/>
+            <a:ext cx="10698480" cy="365760"/>
+          </a:xfrm>
+          <a:prstGeom prst="rect">
+            <a:avLst/>
+          </a:prstGeom>
+          <a:noFill/>
+        </p:spPr>
+        <p:txBody>
+          <a:bodyPr wrap="square">
+            <a:spAutoFit/>
+          </a:bodyPr>
+          <a:lstStyle/>
+          <a:p>
+            <a:pPr>
+              <a:defRPr sz="1100" b="1">
+                <a:solidFill>
+                  <a:srgbClr val="0284C7"/>
+                </a:solidFill>
+                <a:latin typeface="Arial"/>
+              </a:defRPr>
+            </a:pPr>
+            <a:r>
+              <a:t>SLIDE 02/10 • GLUCOTWIN AI — UNSTOP DIGITAL TWIN CHALLENGE 2026</a:t>
+            </a:r>
+          </a:p>
+        </p:txBody>
+      </p:sp>
+      <p:sp>
+        <p:nvSpPr>
+          <p:cNvPr id="3" name="TextBox 2"/>
+          <p:cNvSpPr txBox="1"/>
+          <p:nvPr/>
+        </p:nvSpPr>
+        <p:spPr>
+          <a:xfrm>
+            <a:off x="731520" y="822960"/>
+            <a:ext cx="10698480" cy="640080"/>
+          </a:xfrm>
+          <a:prstGeom prst="rect">
+            <a:avLst/>
+          </a:prstGeom>
+          <a:noFill/>
+        </p:spPr>
+        <p:txBody>
+          <a:bodyPr wrap="square">
+            <a:spAutoFit/>
+          </a:bodyPr>
+          <a:lstStyle/>
+          <a:p>
+            <a:pPr>
+              <a:defRPr sz="2200" b="1">
+                <a:solidFill>
+                  <a:srgbClr val="0C4A6E"/>
+                </a:solidFill>
+                <a:latin typeface="Arial"/>
+              </a:defRPr>
+            </a:pPr>
+            <a:r>
+              <a:t>Clinical Need &amp; The Glycemic Forecasting Problem</a:t>
+            </a:r>
+          </a:p>
+        </p:txBody>
+      </p:sp>
+      <p:sp>
+        <p:nvSpPr>
+          <p:cNvPr id="4" name="TextBox 3"/>
+          <p:cNvSpPr txBox="1"/>
+          <p:nvPr/>
+        </p:nvSpPr>
+        <p:spPr>
+          <a:xfrm>
+            <a:off x="731520" y="1463040"/>
+            <a:ext cx="10698480" cy="365760"/>
+          </a:xfrm>
+          <a:prstGeom prst="rect">
+            <a:avLst/>
+          </a:prstGeom>
+          <a:noFill/>
+        </p:spPr>
+        <p:txBody>
+          <a:bodyPr wrap="square">
+            <a:spAutoFit/>
+          </a:bodyPr>
+          <a:lstStyle/>
+          <a:p>
+            <a:pPr>
+              <a:defRPr sz="1300">
+                <a:solidFill>
+                  <a:srgbClr val="64748B"/>
+                </a:solidFill>
+                <a:latin typeface="Arial"/>
+              </a:defRPr>
+            </a:pPr>
+            <a:r>
+              <a:t>Beyond Reactive Continuous Glucose Monitoring</a:t>
+            </a:r>
+          </a:p>
+        </p:txBody>
+      </p:sp>
+      <p:sp>
+        <p:nvSpPr>
+          <p:cNvPr id="5" name="Rounded Rectangle 4"/>
+          <p:cNvSpPr/>
+          <p:nvPr/>
+        </p:nvSpPr>
+        <p:spPr>
+          <a:xfrm>
+            <a:off x="731520" y="2011680"/>
+            <a:ext cx="10698480" cy="4114800"/>
+          </a:xfrm>
+          <a:prstGeom prst="roundRect">
+            <a:avLst/>
+          </a:prstGeom>
+          <a:solidFill>
+            <a:srgbClr val="F8FAFC"/>
+          </a:solidFill>
+          <a:ln w="12700">
+            <a:solidFill>
+              <a:srgbClr val="CBD5E1"/>
+            </a:solidFill>
+          </a:ln>
+        </p:spPr>
+        <p:style>
+          <a:lnRef idx="1">
+            <a:schemeClr val="accent1"/>
+          </a:lnRef>
+          <a:fillRef idx="3">
+            <a:schemeClr val="accent1"/>
+          </a:fillRef>
+          <a:effectRef idx="2">
+            <a:schemeClr val="accent1"/>
+          </a:effectRef>
+          <a:fontRef idx="minor">
+            <a:schemeClr val="lt1"/>
+          </a:fontRef>
+        </p:style>
+        <p:txBody>
+          <a:bodyPr rtlCol="0" anchor="ctr"/>
+          <a:lstStyle/>
+          <a:p>
+            <a:pPr algn="ctr"/>
+          </a:p>
+        </p:txBody>
+      </p:sp>
+      <p:sp>
+        <p:nvSpPr>
+          <p:cNvPr id="6" name="TextBox 5"/>
+          <p:cNvSpPr txBox="1"/>
+          <p:nvPr/>
+        </p:nvSpPr>
+        <p:spPr>
+          <a:xfrm>
+            <a:off x="1005840" y="2286000"/>
+            <a:ext cx="10149840" cy="3657600"/>
+          </a:xfrm>
+          <a:prstGeom prst="rect">
+            <a:avLst/>
+          </a:prstGeom>
+          <a:noFill/>
+        </p:spPr>
+        <p:txBody>
+          <a:bodyPr wrap="square">
+            <a:spAutoFit/>
+          </a:bodyPr>
+          <a:lstStyle/>
+          <a:p>
+            <a:pPr>
+              <a:spcAft>
+                <a:spcPts val="1400"/>
+              </a:spcAft>
+              <a:defRPr sz="1400">
+                <a:solidFill>
+                  <a:srgbClr val="1E293B"/>
+                </a:solidFill>
+                <a:latin typeface="Arial"/>
+              </a:defRPr>
+            </a:pPr>
+            <a:r>
+              <a:t>•  Glycemic Volatility: Diabetes affects over 530 million adults globally; postprandial spikes and nocturnal hypoglycemia pose acute risks.</a:t>
+            </a:r>
+          </a:p>
+          <a:p>
+            <a:pPr>
+              <a:spcAft>
+                <a:spcPts val="1400"/>
+              </a:spcAft>
+              <a:defRPr sz="1400">
+                <a:solidFill>
+                  <a:srgbClr val="1E293B"/>
+                </a:solidFill>
+                <a:latin typeface="Arial"/>
+              </a:defRPr>
+            </a:pPr>
+            <a:r>
+              <a:t>•  Lagged Observation: Standard CGMs present reactive snapshots with 10-15 minute interstitial physiological delays.</a:t>
+            </a:r>
+          </a:p>
+          <a:p>
+            <a:pPr>
+              <a:spcAft>
+                <a:spcPts val="1400"/>
+              </a:spcAft>
+              <a:defRPr sz="1400">
+                <a:solidFill>
+                  <a:srgbClr val="1E293B"/>
+                </a:solidFill>
+                <a:latin typeface="Arial"/>
+              </a:defRPr>
+            </a:pPr>
+            <a:r>
+              <a:t>•  The Need for Forward Horizon: A 2-hour (120-minute) predictive horizon allows anticipatory lifestyle adjustments.</a:t>
+            </a:r>
+          </a:p>
+          <a:p>
+            <a:pPr>
+              <a:spcAft>
+                <a:spcPts val="1400"/>
+              </a:spcAft>
+              <a:defRPr sz="1400">
+                <a:solidFill>
+                  <a:srgbClr val="1E293B"/>
+                </a:solidFill>
+                <a:latin typeface="Arial"/>
+              </a:defRPr>
+            </a:pPr>
+            <a:r>
+              <a:t>•  Digital Twin Potential: A software twin maintains memory of recent carbohydrates, exertion, and circadian rhythms.</a:t>
+            </a:r>
+          </a:p>
+        </p:txBody>
+      </p:sp>
+      <p:sp>
+        <p:nvSpPr>
+          <p:cNvPr id="7" name="TextBox 6"/>
+          <p:cNvSpPr txBox="1"/>
+          <p:nvPr/>
+        </p:nvSpPr>
+        <p:spPr>
+          <a:xfrm>
+            <a:off x="731520" y="6309360"/>
+            <a:ext cx="10698480" cy="365760"/>
+          </a:xfrm>
+          <a:prstGeom prst="rect">
+            <a:avLst/>
+          </a:prstGeom>
+          <a:noFill/>
+        </p:spPr>
+        <p:txBody>
+          <a:bodyPr wrap="none">
+            <a:spAutoFit/>
+          </a:bodyPr>
+          <a:lstStyle/>
+          <a:p>
+            <a:pPr>
+              <a:defRPr sz="900">
+                <a:solidFill>
+                  <a:srgbClr val="94A3B8"/>
+                </a:solidFill>
+                <a:latin typeface="Arial"/>
+              </a:defRPr>
+            </a:pPr>
+            <a:r>
+              <a:t>Educational Prototype • Not a Medical Device • MIT License • https://github.com/tharundev-123/GlucoTwin_AI</a:t>
             </a:r>
           </a:p>
         </p:txBody>
@@ -3255,69 +3981,276 @@
       <p:grpSpPr/>
       <p:sp>
         <p:nvSpPr>
-          <p:cNvPr id="2" name="Title 1"/>
-          <p:cNvSpPr>
-            <a:spLocks noGrp="1"/>
-          </p:cNvSpPr>
-          <p:nvPr>
-            <p:ph type="title"/>
-          </p:nvPr>
-        </p:nvSpPr>
-        <p:spPr/>
-        <p:txBody>
-          <a:bodyPr/>
-          <a:lstStyle/>
-          <a:p>
-            <a:r>
-              <a:t>Healthcare Use Case</a:t>
-            </a:r>
-          </a:p>
-        </p:txBody>
-      </p:sp>
-      <p:sp>
-        <p:nvSpPr>
-          <p:cNvPr id="3" name="Content Placeholder 2"/>
-          <p:cNvSpPr>
-            <a:spLocks noGrp="1"/>
-          </p:cNvSpPr>
-          <p:nvPr>
-            <p:ph idx="1"/>
-          </p:nvPr>
-        </p:nvSpPr>
-        <p:spPr/>
-        <p:txBody>
-          <a:bodyPr/>
-          <a:lstStyle/>
-          <a:p>
-            <a:pPr>
-              <a:defRPr sz="2200"/>
-            </a:pPr>
-            <a:r>
-              <a:t>Simulated patient history + glucose time series</a:t>
-            </a:r>
-          </a:p>
-          <a:p>
-            <a:pPr>
-              <a:defRPr sz="2200"/>
-            </a:pPr>
-            <a:r>
-              <a:t>Context: activity, meal estimate, sleep and heart rate</a:t>
-            </a:r>
-          </a:p>
-          <a:p>
-            <a:pPr>
-              <a:defRPr sz="2200"/>
-            </a:pPr>
-            <a:r>
-              <a:t>Forecast 30 minutes ahead and show trends in a dashboard</a:t>
-            </a:r>
-          </a:p>
-          <a:p>
-            <a:pPr>
-              <a:defRPr sz="2200"/>
-            </a:pPr>
-            <a:r>
-              <a:t>Outputs are educational, not clinical advice.</a:t>
+          <p:cNvPr id="2" name="TextBox 1"/>
+          <p:cNvSpPr txBox="1"/>
+          <p:nvPr/>
+        </p:nvSpPr>
+        <p:spPr>
+          <a:xfrm>
+            <a:off x="731520" y="457200"/>
+            <a:ext cx="10698480" cy="365760"/>
+          </a:xfrm>
+          <a:prstGeom prst="rect">
+            <a:avLst/>
+          </a:prstGeom>
+          <a:noFill/>
+        </p:spPr>
+        <p:txBody>
+          <a:bodyPr wrap="square">
+            <a:spAutoFit/>
+          </a:bodyPr>
+          <a:lstStyle/>
+          <a:p>
+            <a:pPr>
+              <a:defRPr sz="1100" b="1">
+                <a:solidFill>
+                  <a:srgbClr val="0284C7"/>
+                </a:solidFill>
+                <a:latin typeface="Arial"/>
+              </a:defRPr>
+            </a:pPr>
+            <a:r>
+              <a:t>SLIDE 03/10 • GLUCOTWIN AI — UNSTOP DIGITAL TWIN CHALLENGE 2026</a:t>
+            </a:r>
+          </a:p>
+        </p:txBody>
+      </p:sp>
+      <p:sp>
+        <p:nvSpPr>
+          <p:cNvPr id="3" name="TextBox 2"/>
+          <p:cNvSpPr txBox="1"/>
+          <p:nvPr/>
+        </p:nvSpPr>
+        <p:spPr>
+          <a:xfrm>
+            <a:off x="731520" y="822960"/>
+            <a:ext cx="10698480" cy="640080"/>
+          </a:xfrm>
+          <a:prstGeom prst="rect">
+            <a:avLst/>
+          </a:prstGeom>
+          <a:noFill/>
+        </p:spPr>
+        <p:txBody>
+          <a:bodyPr wrap="square">
+            <a:spAutoFit/>
+          </a:bodyPr>
+          <a:lstStyle/>
+          <a:p>
+            <a:pPr>
+              <a:defRPr sz="2200" b="1">
+                <a:solidFill>
+                  <a:srgbClr val="0C4A6E"/>
+                </a:solidFill>
+                <a:latin typeface="Arial"/>
+              </a:defRPr>
+            </a:pPr>
+            <a:r>
+              <a:t>The GlucoTwin AI Solution Concept</a:t>
+            </a:r>
+          </a:p>
+        </p:txBody>
+      </p:sp>
+      <p:sp>
+        <p:nvSpPr>
+          <p:cNvPr id="4" name="TextBox 3"/>
+          <p:cNvSpPr txBox="1"/>
+          <p:nvPr/>
+        </p:nvSpPr>
+        <p:spPr>
+          <a:xfrm>
+            <a:off x="731520" y="1463040"/>
+            <a:ext cx="10698480" cy="365760"/>
+          </a:xfrm>
+          <a:prstGeom prst="rect">
+            <a:avLst/>
+          </a:prstGeom>
+          <a:noFill/>
+        </p:spPr>
+        <p:txBody>
+          <a:bodyPr wrap="square">
+            <a:spAutoFit/>
+          </a:bodyPr>
+          <a:lstStyle/>
+          <a:p>
+            <a:pPr>
+              <a:defRPr sz="1300">
+                <a:solidFill>
+                  <a:srgbClr val="64748B"/>
+                </a:solidFill>
+                <a:latin typeface="Arial"/>
+              </a:defRPr>
+            </a:pPr>
+            <a:r>
+              <a:t>A Closed-Loop Virtual Metabolic Avatar</a:t>
+            </a:r>
+          </a:p>
+        </p:txBody>
+      </p:sp>
+      <p:sp>
+        <p:nvSpPr>
+          <p:cNvPr id="5" name="Rounded Rectangle 4"/>
+          <p:cNvSpPr/>
+          <p:nvPr/>
+        </p:nvSpPr>
+        <p:spPr>
+          <a:xfrm>
+            <a:off x="731520" y="2011680"/>
+            <a:ext cx="10698480" cy="4114800"/>
+          </a:xfrm>
+          <a:prstGeom prst="roundRect">
+            <a:avLst/>
+          </a:prstGeom>
+          <a:solidFill>
+            <a:srgbClr val="F8FAFC"/>
+          </a:solidFill>
+          <a:ln w="12700">
+            <a:solidFill>
+              <a:srgbClr val="CBD5E1"/>
+            </a:solidFill>
+          </a:ln>
+        </p:spPr>
+        <p:style>
+          <a:lnRef idx="1">
+            <a:schemeClr val="accent1"/>
+          </a:lnRef>
+          <a:fillRef idx="3">
+            <a:schemeClr val="accent1"/>
+          </a:fillRef>
+          <a:effectRef idx="2">
+            <a:schemeClr val="accent1"/>
+          </a:effectRef>
+          <a:fontRef idx="minor">
+            <a:schemeClr val="lt1"/>
+          </a:fontRef>
+        </p:style>
+        <p:txBody>
+          <a:bodyPr rtlCol="0" anchor="ctr"/>
+          <a:lstStyle/>
+          <a:p>
+            <a:pPr algn="ctr"/>
+          </a:p>
+        </p:txBody>
+      </p:sp>
+      <p:sp>
+        <p:nvSpPr>
+          <p:cNvPr id="6" name="TextBox 5"/>
+          <p:cNvSpPr txBox="1"/>
+          <p:nvPr/>
+        </p:nvSpPr>
+        <p:spPr>
+          <a:xfrm>
+            <a:off x="1005840" y="2286000"/>
+            <a:ext cx="10149840" cy="3657600"/>
+          </a:xfrm>
+          <a:prstGeom prst="rect">
+            <a:avLst/>
+          </a:prstGeom>
+          <a:noFill/>
+        </p:spPr>
+        <p:txBody>
+          <a:bodyPr wrap="square">
+            <a:spAutoFit/>
+          </a:bodyPr>
+          <a:lstStyle/>
+          <a:p>
+            <a:pPr>
+              <a:spcAft>
+                <a:spcPts val="1400"/>
+              </a:spcAft>
+              <a:defRPr sz="1400">
+                <a:solidFill>
+                  <a:srgbClr val="1E293B"/>
+                </a:solidFill>
+                <a:latin typeface="Arial"/>
+              </a:defRPr>
+            </a:pPr>
+            <a:r>
+              <a:t>•  Virtual Twin Synchronization: Ingests 5-minute telemetry ticks into an in-memory sliding window state buffer.</a:t>
+            </a:r>
+          </a:p>
+          <a:p>
+            <a:pPr>
+              <a:spcAft>
+                <a:spcPts val="1400"/>
+              </a:spcAft>
+              <a:defRPr sz="1400">
+                <a:solidFill>
+                  <a:srgbClr val="1E293B"/>
+                </a:solidFill>
+                <a:latin typeface="Arial"/>
+              </a:defRPr>
+            </a:pPr>
+            <a:r>
+              <a:t>•  Multi-Modal Context Integration: Blends glucose values with heart rate, physical activity index, meal carbs, and sleep.</a:t>
+            </a:r>
+          </a:p>
+          <a:p>
+            <a:pPr>
+              <a:spcAft>
+                <a:spcPts val="1400"/>
+              </a:spcAft>
+              <a:defRPr sz="1400">
+                <a:solidFill>
+                  <a:srgbClr val="1E293B"/>
+                </a:solidFill>
+                <a:latin typeface="Arial"/>
+              </a:defRPr>
+            </a:pPr>
+            <a:r>
+              <a:t>•  Defensible Uncertainty: Inter-tree variance delivers calibrated 95% confidence bounds rather than fabricated certainty.</a:t>
+            </a:r>
+          </a:p>
+          <a:p>
+            <a:pPr>
+              <a:spcAft>
+                <a:spcPts val="1400"/>
+              </a:spcAft>
+              <a:defRPr sz="1400">
+                <a:solidFill>
+                  <a:srgbClr val="1E293B"/>
+                </a:solidFill>
+                <a:latin typeface="Arial"/>
+              </a:defRPr>
+            </a:pPr>
+            <a:r>
+              <a:t>•  Transparent Simulation Controls: Provides real-time streaming, pause, step (+5m/+30m), reset, and what-if sandbox.</a:t>
+            </a:r>
+          </a:p>
+        </p:txBody>
+      </p:sp>
+      <p:sp>
+        <p:nvSpPr>
+          <p:cNvPr id="7" name="TextBox 6"/>
+          <p:cNvSpPr txBox="1"/>
+          <p:nvPr/>
+        </p:nvSpPr>
+        <p:spPr>
+          <a:xfrm>
+            <a:off x="731520" y="6309360"/>
+            <a:ext cx="10698480" cy="365760"/>
+          </a:xfrm>
+          <a:prstGeom prst="rect">
+            <a:avLst/>
+          </a:prstGeom>
+          <a:noFill/>
+        </p:spPr>
+        <p:txBody>
+          <a:bodyPr wrap="none">
+            <a:spAutoFit/>
+          </a:bodyPr>
+          <a:lstStyle/>
+          <a:p>
+            <a:pPr>
+              <a:defRPr sz="900">
+                <a:solidFill>
+                  <a:srgbClr val="94A3B8"/>
+                </a:solidFill>
+                <a:latin typeface="Arial"/>
+              </a:defRPr>
+            </a:pPr>
+            <a:r>
+              <a:t>Educational Prototype • Not a Medical Device • MIT License • https://github.com/tharundev-123/GlucoTwin_AI</a:t>
             </a:r>
           </a:p>
         </p:txBody>
@@ -3342,77 +4275,276 @@
       <p:grpSpPr/>
       <p:sp>
         <p:nvSpPr>
-          <p:cNvPr id="2" name="Title 1"/>
-          <p:cNvSpPr>
-            <a:spLocks noGrp="1"/>
-          </p:cNvSpPr>
-          <p:nvPr>
-            <p:ph type="title"/>
-          </p:nvPr>
-        </p:nvSpPr>
-        <p:spPr/>
-        <p:txBody>
-          <a:bodyPr/>
-          <a:lstStyle/>
-          <a:p>
-            <a:r>
-              <a:t>System Architecture</a:t>
-            </a:r>
-          </a:p>
-        </p:txBody>
-      </p:sp>
-      <p:sp>
-        <p:nvSpPr>
-          <p:cNvPr id="3" name="Content Placeholder 2"/>
-          <p:cNvSpPr>
-            <a:spLocks noGrp="1"/>
-          </p:cNvSpPr>
-          <p:nvPr>
-            <p:ph idx="1"/>
-          </p:nvPr>
-        </p:nvSpPr>
-        <p:spPr/>
-        <p:txBody>
-          <a:bodyPr/>
-          <a:lstStyle/>
-          <a:p>
-            <a:pPr>
-              <a:defRPr sz="2200"/>
-            </a:pPr>
-            <a:r>
-              <a:t>Data generation / permitted data</a:t>
-            </a:r>
-          </a:p>
-          <a:p>
-            <a:pPr>
-              <a:defRPr sz="2200"/>
-            </a:pPr>
-            <a:r>
-              <a:t>Validation and lag/rolling feature engineering</a:t>
-            </a:r>
-          </a:p>
-          <a:p>
-            <a:pPr>
-              <a:defRPr sz="2200"/>
-            </a:pPr>
-            <a:r>
-              <a:t>Random Forest regression baseline</a:t>
-            </a:r>
-          </a:p>
-          <a:p>
-            <a:pPr>
-              <a:defRPr sz="2200"/>
-            </a:pPr>
-            <a:r>
-              <a:t>FastAPI endpoints → dashboard / charts</a:t>
-            </a:r>
-          </a:p>
-          <a:p>
-            <a:pPr>
-              <a:defRPr sz="2200"/>
-            </a:pPr>
-            <a:r>
-              <a:t>See architecture.pdf for the diagram.</a:t>
+          <p:cNvPr id="2" name="TextBox 1"/>
+          <p:cNvSpPr txBox="1"/>
+          <p:nvPr/>
+        </p:nvSpPr>
+        <p:spPr>
+          <a:xfrm>
+            <a:off x="731520" y="457200"/>
+            <a:ext cx="10698480" cy="365760"/>
+          </a:xfrm>
+          <a:prstGeom prst="rect">
+            <a:avLst/>
+          </a:prstGeom>
+          <a:noFill/>
+        </p:spPr>
+        <p:txBody>
+          <a:bodyPr wrap="square">
+            <a:spAutoFit/>
+          </a:bodyPr>
+          <a:lstStyle/>
+          <a:p>
+            <a:pPr>
+              <a:defRPr sz="1100" b="1">
+                <a:solidFill>
+                  <a:srgbClr val="0284C7"/>
+                </a:solidFill>
+                <a:latin typeface="Arial"/>
+              </a:defRPr>
+            </a:pPr>
+            <a:r>
+              <a:t>SLIDE 04/10 • GLUCOTWIN AI — UNSTOP DIGITAL TWIN CHALLENGE 2026</a:t>
+            </a:r>
+          </a:p>
+        </p:txBody>
+      </p:sp>
+      <p:sp>
+        <p:nvSpPr>
+          <p:cNvPr id="3" name="TextBox 2"/>
+          <p:cNvSpPr txBox="1"/>
+          <p:nvPr/>
+        </p:nvSpPr>
+        <p:spPr>
+          <a:xfrm>
+            <a:off x="731520" y="822960"/>
+            <a:ext cx="10698480" cy="640080"/>
+          </a:xfrm>
+          <a:prstGeom prst="rect">
+            <a:avLst/>
+          </a:prstGeom>
+          <a:noFill/>
+        </p:spPr>
+        <p:txBody>
+          <a:bodyPr wrap="square">
+            <a:spAutoFit/>
+          </a:bodyPr>
+          <a:lstStyle/>
+          <a:p>
+            <a:pPr>
+              <a:defRPr sz="2200" b="1">
+                <a:solidFill>
+                  <a:srgbClr val="0C4A6E"/>
+                </a:solidFill>
+                <a:latin typeface="Arial"/>
+              </a:defRPr>
+            </a:pPr>
+            <a:r>
+              <a:t>Healthcare Use Case &amp; Regulatory Non-Diagnostic Scope</a:t>
+            </a:r>
+          </a:p>
+        </p:txBody>
+      </p:sp>
+      <p:sp>
+        <p:nvSpPr>
+          <p:cNvPr id="4" name="TextBox 3"/>
+          <p:cNvSpPr txBox="1"/>
+          <p:nvPr/>
+        </p:nvSpPr>
+        <p:spPr>
+          <a:xfrm>
+            <a:off x="731520" y="1463040"/>
+            <a:ext cx="10698480" cy="365760"/>
+          </a:xfrm>
+          <a:prstGeom prst="rect">
+            <a:avLst/>
+          </a:prstGeom>
+          <a:noFill/>
+        </p:spPr>
+        <p:txBody>
+          <a:bodyPr wrap="square">
+            <a:spAutoFit/>
+          </a:bodyPr>
+          <a:lstStyle/>
+          <a:p>
+            <a:pPr>
+              <a:defRPr sz="1300">
+                <a:solidFill>
+                  <a:srgbClr val="64748B"/>
+                </a:solidFill>
+                <a:latin typeface="Arial"/>
+              </a:defRPr>
+            </a:pPr>
+            <a:r>
+              <a:t>Safety-by-Design &amp; Clear Boundaries</a:t>
+            </a:r>
+          </a:p>
+        </p:txBody>
+      </p:sp>
+      <p:sp>
+        <p:nvSpPr>
+          <p:cNvPr id="5" name="Rounded Rectangle 4"/>
+          <p:cNvSpPr/>
+          <p:nvPr/>
+        </p:nvSpPr>
+        <p:spPr>
+          <a:xfrm>
+            <a:off x="731520" y="2011680"/>
+            <a:ext cx="10698480" cy="4114800"/>
+          </a:xfrm>
+          <a:prstGeom prst="roundRect">
+            <a:avLst/>
+          </a:prstGeom>
+          <a:solidFill>
+            <a:srgbClr val="F8FAFC"/>
+          </a:solidFill>
+          <a:ln w="12700">
+            <a:solidFill>
+              <a:srgbClr val="CBD5E1"/>
+            </a:solidFill>
+          </a:ln>
+        </p:spPr>
+        <p:style>
+          <a:lnRef idx="1">
+            <a:schemeClr val="accent1"/>
+          </a:lnRef>
+          <a:fillRef idx="3">
+            <a:schemeClr val="accent1"/>
+          </a:fillRef>
+          <a:effectRef idx="2">
+            <a:schemeClr val="accent1"/>
+          </a:effectRef>
+          <a:fontRef idx="minor">
+            <a:schemeClr val="lt1"/>
+          </a:fontRef>
+        </p:style>
+        <p:txBody>
+          <a:bodyPr rtlCol="0" anchor="ctr"/>
+          <a:lstStyle/>
+          <a:p>
+            <a:pPr algn="ctr"/>
+          </a:p>
+        </p:txBody>
+      </p:sp>
+      <p:sp>
+        <p:nvSpPr>
+          <p:cNvPr id="6" name="TextBox 5"/>
+          <p:cNvSpPr txBox="1"/>
+          <p:nvPr/>
+        </p:nvSpPr>
+        <p:spPr>
+          <a:xfrm>
+            <a:off x="1005840" y="2286000"/>
+            <a:ext cx="10149840" cy="3657600"/>
+          </a:xfrm>
+          <a:prstGeom prst="rect">
+            <a:avLst/>
+          </a:prstGeom>
+          <a:noFill/>
+        </p:spPr>
+        <p:txBody>
+          <a:bodyPr wrap="square">
+            <a:spAutoFit/>
+          </a:bodyPr>
+          <a:lstStyle/>
+          <a:p>
+            <a:pPr>
+              <a:spcAft>
+                <a:spcPts val="1400"/>
+              </a:spcAft>
+              <a:defRPr sz="1400">
+                <a:solidFill>
+                  <a:srgbClr val="1E293B"/>
+                </a:solidFill>
+                <a:latin typeface="Arial"/>
+              </a:defRPr>
+            </a:pPr>
+            <a:r>
+              <a:t>•  Target Use Case: Research testbed, metabolic education, and simulation environment for digital health researchers.</a:t>
+            </a:r>
+          </a:p>
+          <a:p>
+            <a:pPr>
+              <a:spcAft>
+                <a:spcPts val="1400"/>
+              </a:spcAft>
+              <a:defRPr sz="1400">
+                <a:solidFill>
+                  <a:srgbClr val="1E293B"/>
+                </a:solidFill>
+                <a:latin typeface="Arial"/>
+              </a:defRPr>
+            </a:pPr>
+            <a:r>
+              <a:t>•  Strict Safety Boundaries: Does NOT provide insulin dose titration, medical diagnosis, or emergency intervention.</a:t>
+            </a:r>
+          </a:p>
+          <a:p>
+            <a:pPr>
+              <a:spcAft>
+                <a:spcPts val="1400"/>
+              </a:spcAft>
+              <a:defRPr sz="1400">
+                <a:solidFill>
+                  <a:srgbClr val="1E293B"/>
+                </a:solidFill>
+                <a:latin typeface="Arial"/>
+              </a:defRPr>
+            </a:pPr>
+            <a:r>
+              <a:t>•  Regulatory Scope: Clarified as non-SaMD (Software as a Medical Device) under FDA 21 CFR 860 and EU MDR Annex VIII.</a:t>
+            </a:r>
+          </a:p>
+          <a:p>
+            <a:pPr>
+              <a:spcAft>
+                <a:spcPts val="1400"/>
+              </a:spcAft>
+              <a:defRPr sz="1400">
+                <a:solidFill>
+                  <a:srgbClr val="1E293B"/>
+                </a:solidFill>
+                <a:latin typeface="Arial"/>
+              </a:defRPr>
+            </a:pPr>
+            <a:r>
+              <a:t>•  Patient Privacy: Zero collection of Protected Health Information (PHI); utilizes strictly synthetic, de-identified identities.</a:t>
+            </a:r>
+          </a:p>
+        </p:txBody>
+      </p:sp>
+      <p:sp>
+        <p:nvSpPr>
+          <p:cNvPr id="7" name="TextBox 6"/>
+          <p:cNvSpPr txBox="1"/>
+          <p:nvPr/>
+        </p:nvSpPr>
+        <p:spPr>
+          <a:xfrm>
+            <a:off x="731520" y="6309360"/>
+            <a:ext cx="10698480" cy="365760"/>
+          </a:xfrm>
+          <a:prstGeom prst="rect">
+            <a:avLst/>
+          </a:prstGeom>
+          <a:noFill/>
+        </p:spPr>
+        <p:txBody>
+          <a:bodyPr wrap="none">
+            <a:spAutoFit/>
+          </a:bodyPr>
+          <a:lstStyle/>
+          <a:p>
+            <a:pPr>
+              <a:defRPr sz="900">
+                <a:solidFill>
+                  <a:srgbClr val="94A3B8"/>
+                </a:solidFill>
+                <a:latin typeface="Arial"/>
+              </a:defRPr>
+            </a:pPr>
+            <a:r>
+              <a:t>Educational Prototype • Not a Medical Device • MIT License • https://github.com/tharundev-123/GlucoTwin_AI</a:t>
             </a:r>
           </a:p>
         </p:txBody>
@@ -3437,69 +4569,276 @@
       <p:grpSpPr/>
       <p:sp>
         <p:nvSpPr>
-          <p:cNvPr id="2" name="Title 1"/>
-          <p:cNvSpPr>
-            <a:spLocks noGrp="1"/>
-          </p:cNvSpPr>
-          <p:nvPr>
-            <p:ph type="title"/>
-          </p:nvPr>
-        </p:nvSpPr>
-        <p:spPr/>
-        <p:txBody>
-          <a:bodyPr/>
-          <a:lstStyle/>
-          <a:p>
-            <a:r>
-              <a:t>AI/ML Approach</a:t>
-            </a:r>
-          </a:p>
-        </p:txBody>
-      </p:sp>
-      <p:sp>
-        <p:nvSpPr>
-          <p:cNvPr id="3" name="Content Placeholder 2"/>
-          <p:cNvSpPr>
-            <a:spLocks noGrp="1"/>
-          </p:cNvSpPr>
-          <p:nvPr>
-            <p:ph idx="1"/>
-          </p:nvPr>
-        </p:nvSpPr>
-        <p:spPr/>
-        <p:txBody>
-          <a:bodyPr/>
-          <a:lstStyle/>
-          <a:p>
-            <a:pPr>
-              <a:defRPr sz="2200"/>
-            </a:pPr>
-            <a:r>
-              <a:t>Python, pandas, NumPy and scikit-learn</a:t>
-            </a:r>
-          </a:p>
-          <a:p>
-            <a:pPr>
-              <a:defRPr sz="2200"/>
-            </a:pPr>
-            <a:r>
-              <a:t>Chronological 80/20 train/test split</a:t>
-            </a:r>
-          </a:p>
-          <a:p>
-            <a:pPr>
-              <a:defRPr sz="2200"/>
-            </a:pPr>
-            <a:r>
-              <a:t>Metrics: MAE and RMSE</a:t>
-            </a:r>
-          </a:p>
-          <a:p>
-            <a:pPr>
-              <a:defRPr sz="2200"/>
-            </a:pPr>
-            <a:r>
-              <a:t>Synthetic data only; results do not establish clinical validity.</a:t>
+          <p:cNvPr id="2" name="TextBox 1"/>
+          <p:cNvSpPr txBox="1"/>
+          <p:nvPr/>
+        </p:nvSpPr>
+        <p:spPr>
+          <a:xfrm>
+            <a:off x="731520" y="457200"/>
+            <a:ext cx="10698480" cy="365760"/>
+          </a:xfrm>
+          <a:prstGeom prst="rect">
+            <a:avLst/>
+          </a:prstGeom>
+          <a:noFill/>
+        </p:spPr>
+        <p:txBody>
+          <a:bodyPr wrap="square">
+            <a:spAutoFit/>
+          </a:bodyPr>
+          <a:lstStyle/>
+          <a:p>
+            <a:pPr>
+              <a:defRPr sz="1100" b="1">
+                <a:solidFill>
+                  <a:srgbClr val="0284C7"/>
+                </a:solidFill>
+                <a:latin typeface="Arial"/>
+              </a:defRPr>
+            </a:pPr>
+            <a:r>
+              <a:t>SLIDE 05/10 • GLUCOTWIN AI — UNSTOP DIGITAL TWIN CHALLENGE 2026</a:t>
+            </a:r>
+          </a:p>
+        </p:txBody>
+      </p:sp>
+      <p:sp>
+        <p:nvSpPr>
+          <p:cNvPr id="3" name="TextBox 2"/>
+          <p:cNvSpPr txBox="1"/>
+          <p:nvPr/>
+        </p:nvSpPr>
+        <p:spPr>
+          <a:xfrm>
+            <a:off x="731520" y="822960"/>
+            <a:ext cx="10698480" cy="640080"/>
+          </a:xfrm>
+          <a:prstGeom prst="rect">
+            <a:avLst/>
+          </a:prstGeom>
+          <a:noFill/>
+        </p:spPr>
+        <p:txBody>
+          <a:bodyPr wrap="square">
+            <a:spAutoFit/>
+          </a:bodyPr>
+          <a:lstStyle/>
+          <a:p>
+            <a:pPr>
+              <a:defRPr sz="2200" b="1">
+                <a:solidFill>
+                  <a:srgbClr val="0C4A6E"/>
+                </a:solidFill>
+                <a:latin typeface="Arial"/>
+              </a:defRPr>
+            </a:pPr>
+            <a:r>
+              <a:t>End-to-End Four-Tier System Architecture</a:t>
+            </a:r>
+          </a:p>
+        </p:txBody>
+      </p:sp>
+      <p:sp>
+        <p:nvSpPr>
+          <p:cNvPr id="4" name="TextBox 3"/>
+          <p:cNvSpPr txBox="1"/>
+          <p:nvPr/>
+        </p:nvSpPr>
+        <p:spPr>
+          <a:xfrm>
+            <a:off x="731520" y="1463040"/>
+            <a:ext cx="10698480" cy="365760"/>
+          </a:xfrm>
+          <a:prstGeom prst="rect">
+            <a:avLst/>
+          </a:prstGeom>
+          <a:noFill/>
+        </p:spPr>
+        <p:txBody>
+          <a:bodyPr wrap="square">
+            <a:spAutoFit/>
+          </a:bodyPr>
+          <a:lstStyle/>
+          <a:p>
+            <a:pPr>
+              <a:defRPr sz="1300">
+                <a:solidFill>
+                  <a:srgbClr val="64748B"/>
+                </a:solidFill>
+                <a:latin typeface="Arial"/>
+              </a:defRPr>
+            </a:pPr>
+            <a:r>
+              <a:t>From Deterministic Physics to Interactive Dashboard</a:t>
+            </a:r>
+          </a:p>
+        </p:txBody>
+      </p:sp>
+      <p:sp>
+        <p:nvSpPr>
+          <p:cNvPr id="5" name="Rounded Rectangle 4"/>
+          <p:cNvSpPr/>
+          <p:nvPr/>
+        </p:nvSpPr>
+        <p:spPr>
+          <a:xfrm>
+            <a:off x="731520" y="2011680"/>
+            <a:ext cx="10698480" cy="4114800"/>
+          </a:xfrm>
+          <a:prstGeom prst="roundRect">
+            <a:avLst/>
+          </a:prstGeom>
+          <a:solidFill>
+            <a:srgbClr val="F8FAFC"/>
+          </a:solidFill>
+          <a:ln w="12700">
+            <a:solidFill>
+              <a:srgbClr val="CBD5E1"/>
+            </a:solidFill>
+          </a:ln>
+        </p:spPr>
+        <p:style>
+          <a:lnRef idx="1">
+            <a:schemeClr val="accent1"/>
+          </a:lnRef>
+          <a:fillRef idx="3">
+            <a:schemeClr val="accent1"/>
+          </a:fillRef>
+          <a:effectRef idx="2">
+            <a:schemeClr val="accent1"/>
+          </a:effectRef>
+          <a:fontRef idx="minor">
+            <a:schemeClr val="lt1"/>
+          </a:fontRef>
+        </p:style>
+        <p:txBody>
+          <a:bodyPr rtlCol="0" anchor="ctr"/>
+          <a:lstStyle/>
+          <a:p>
+            <a:pPr algn="ctr"/>
+          </a:p>
+        </p:txBody>
+      </p:sp>
+      <p:sp>
+        <p:nvSpPr>
+          <p:cNvPr id="6" name="TextBox 5"/>
+          <p:cNvSpPr txBox="1"/>
+          <p:nvPr/>
+        </p:nvSpPr>
+        <p:spPr>
+          <a:xfrm>
+            <a:off x="1005840" y="2286000"/>
+            <a:ext cx="10149840" cy="3657600"/>
+          </a:xfrm>
+          <a:prstGeom prst="rect">
+            <a:avLst/>
+          </a:prstGeom>
+          <a:noFill/>
+        </p:spPr>
+        <p:txBody>
+          <a:bodyPr wrap="square">
+            <a:spAutoFit/>
+          </a:bodyPr>
+          <a:lstStyle/>
+          <a:p>
+            <a:pPr>
+              <a:spcAft>
+                <a:spcPts val="1400"/>
+              </a:spcAft>
+              <a:defRPr sz="1400">
+                <a:solidFill>
+                  <a:srgbClr val="1E293B"/>
+                </a:solidFill>
+                <a:latin typeface="Arial"/>
+              </a:defRPr>
+            </a:pPr>
+            <a:r>
+              <a:t>•  Tier 1 - Telemetry Engine: Deterministic synthetic generator modeling digestion curves and homeostatic drift.</a:t>
+            </a:r>
+          </a:p>
+          <a:p>
+            <a:pPr>
+              <a:spcAft>
+                <a:spcPts val="1400"/>
+              </a:spcAft>
+              <a:defRPr sz="1400">
+                <a:solidFill>
+                  <a:srgbClr val="1E293B"/>
+                </a:solidFill>
+                <a:latin typeface="Arial"/>
+              </a:defRPr>
+            </a:pPr>
+            <a:r>
+              <a:t>•  Tier 2 - Feature Engineering: 23 backward-looking features including multi-step lags, rolling statistics, and harmonics.</a:t>
+            </a:r>
+          </a:p>
+          <a:p>
+            <a:pPr>
+              <a:spcAft>
+                <a:spcPts val="1400"/>
+              </a:spcAft>
+              <a:defRPr sz="1400">
+                <a:solidFill>
+                  <a:srgbClr val="1E293B"/>
+                </a:solidFill>
+                <a:latin typeface="Arial"/>
+              </a:defRPr>
+            </a:pPr>
+            <a:r>
+              <a:t>•  Tier 3 - ML Ensemble: 150-tree Random Forest optimized for 24-step (120 min) horizon with uncertainty estimation.</a:t>
+            </a:r>
+          </a:p>
+          <a:p>
+            <a:pPr>
+              <a:spcAft>
+                <a:spcPts val="1400"/>
+              </a:spcAft>
+              <a:defRPr sz="1400">
+                <a:solidFill>
+                  <a:srgbClr val="1E293B"/>
+                </a:solidFill>
+                <a:latin typeface="Arial"/>
+              </a:defRPr>
+            </a:pPr>
+            <a:r>
+              <a:t>•  Tier 4 - Delivery: FastAPI REST services (/api/v1/...) paired with React 18, TypeScript, Tailwind CSS, and Recharts.</a:t>
+            </a:r>
+          </a:p>
+        </p:txBody>
+      </p:sp>
+      <p:sp>
+        <p:nvSpPr>
+          <p:cNvPr id="7" name="TextBox 6"/>
+          <p:cNvSpPr txBox="1"/>
+          <p:nvPr/>
+        </p:nvSpPr>
+        <p:spPr>
+          <a:xfrm>
+            <a:off x="731520" y="6309360"/>
+            <a:ext cx="10698480" cy="365760"/>
+          </a:xfrm>
+          <a:prstGeom prst="rect">
+            <a:avLst/>
+          </a:prstGeom>
+          <a:noFill/>
+        </p:spPr>
+        <p:txBody>
+          <a:bodyPr wrap="none">
+            <a:spAutoFit/>
+          </a:bodyPr>
+          <a:lstStyle/>
+          <a:p>
+            <a:pPr>
+              <a:defRPr sz="900">
+                <a:solidFill>
+                  <a:srgbClr val="94A3B8"/>
+                </a:solidFill>
+                <a:latin typeface="Arial"/>
+              </a:defRPr>
+            </a:pPr>
+            <a:r>
+              <a:t>Educational Prototype • Not a Medical Device • MIT License • https://github.com/tharundev-123/GlucoTwin_AI</a:t>
             </a:r>
           </a:p>
         </p:txBody>
@@ -3524,69 +4863,276 @@
       <p:grpSpPr/>
       <p:sp>
         <p:nvSpPr>
-          <p:cNvPr id="2" name="Title 1"/>
-          <p:cNvSpPr>
-            <a:spLocks noGrp="1"/>
-          </p:cNvSpPr>
-          <p:nvPr>
-            <p:ph type="title"/>
-          </p:nvPr>
-        </p:nvSpPr>
-        <p:spPr/>
-        <p:txBody>
-          <a:bodyPr/>
-          <a:lstStyle/>
-          <a:p>
-            <a:r>
-              <a:t>Working Prototype</a:t>
-            </a:r>
-          </a:p>
-        </p:txBody>
-      </p:sp>
-      <p:sp>
-        <p:nvSpPr>
-          <p:cNvPr id="3" name="Content Placeholder 2"/>
-          <p:cNvSpPr>
-            <a:spLocks noGrp="1"/>
-          </p:cNvSpPr>
-          <p:nvPr>
-            <p:ph idx="1"/>
-          </p:nvPr>
-        </p:nvSpPr>
-        <p:spPr/>
-        <p:txBody>
-          <a:bodyPr/>
-          <a:lstStyle/>
-          <a:p>
-            <a:pPr>
-              <a:defRPr sz="2200"/>
-            </a:pPr>
-            <a:r>
-              <a:t>GET /health</a:t>
-            </a:r>
-          </a:p>
-          <a:p>
-            <a:pPr>
-              <a:defRPr sz="2200"/>
-            </a:pPr>
-            <a:r>
-              <a:t>GET /twin/demo-patient</a:t>
-            </a:r>
-          </a:p>
-          <a:p>
-            <a:pPr>
-              <a:defRPr sz="2200"/>
-            </a:pPr>
-            <a:r>
-              <a:t>GET /forecast/demo-patient?horizon_minutes=30</a:t>
-            </a:r>
-          </a:p>
-          <a:p>
-            <a:pPr>
-              <a:defRPr sz="2200"/>
-            </a:pPr>
-            <a:r>
-              <a:t>Interactive API docs at /docs after running locally.</a:t>
+          <p:cNvPr id="2" name="TextBox 1"/>
+          <p:cNvSpPr txBox="1"/>
+          <p:nvPr/>
+        </p:nvSpPr>
+        <p:spPr>
+          <a:xfrm>
+            <a:off x="731520" y="457200"/>
+            <a:ext cx="10698480" cy="365760"/>
+          </a:xfrm>
+          <a:prstGeom prst="rect">
+            <a:avLst/>
+          </a:prstGeom>
+          <a:noFill/>
+        </p:spPr>
+        <p:txBody>
+          <a:bodyPr wrap="square">
+            <a:spAutoFit/>
+          </a:bodyPr>
+          <a:lstStyle/>
+          <a:p>
+            <a:pPr>
+              <a:defRPr sz="1100" b="1">
+                <a:solidFill>
+                  <a:srgbClr val="0284C7"/>
+                </a:solidFill>
+                <a:latin typeface="Arial"/>
+              </a:defRPr>
+            </a:pPr>
+            <a:r>
+              <a:t>SLIDE 06/10 • GLUCOTWIN AI — UNSTOP DIGITAL TWIN CHALLENGE 2026</a:t>
+            </a:r>
+          </a:p>
+        </p:txBody>
+      </p:sp>
+      <p:sp>
+        <p:nvSpPr>
+          <p:cNvPr id="3" name="TextBox 2"/>
+          <p:cNvSpPr txBox="1"/>
+          <p:nvPr/>
+        </p:nvSpPr>
+        <p:spPr>
+          <a:xfrm>
+            <a:off x="731520" y="822960"/>
+            <a:ext cx="10698480" cy="640080"/>
+          </a:xfrm>
+          <a:prstGeom prst="rect">
+            <a:avLst/>
+          </a:prstGeom>
+          <a:noFill/>
+        </p:spPr>
+        <p:txBody>
+          <a:bodyPr wrap="square">
+            <a:spAutoFit/>
+          </a:bodyPr>
+          <a:lstStyle/>
+          <a:p>
+            <a:pPr>
+              <a:defRPr sz="2200" b="1">
+                <a:solidFill>
+                  <a:srgbClr val="0C4A6E"/>
+                </a:solidFill>
+                <a:latin typeface="Arial"/>
+              </a:defRPr>
+            </a:pPr>
+            <a:r>
+              <a:t>Synthetic Physiological Dataset &amp; Generation Dynamics</a:t>
+            </a:r>
+          </a:p>
+        </p:txBody>
+      </p:sp>
+      <p:sp>
+        <p:nvSpPr>
+          <p:cNvPr id="4" name="TextBox 3"/>
+          <p:cNvSpPr txBox="1"/>
+          <p:nvPr/>
+        </p:nvSpPr>
+        <p:spPr>
+          <a:xfrm>
+            <a:off x="731520" y="1463040"/>
+            <a:ext cx="10698480" cy="365760"/>
+          </a:xfrm>
+          <a:prstGeom prst="rect">
+            <a:avLst/>
+          </a:prstGeom>
+          <a:noFill/>
+        </p:spPr>
+        <p:txBody>
+          <a:bodyPr wrap="square">
+            <a:spAutoFit/>
+          </a:bodyPr>
+          <a:lstStyle/>
+          <a:p>
+            <a:pPr>
+              <a:defRPr sz="1300">
+                <a:solidFill>
+                  <a:srgbClr val="64748B"/>
+                </a:solidFill>
+                <a:latin typeface="Arial"/>
+              </a:defRPr>
+            </a:pPr>
+            <a:r>
+              <a:t>Biologically Grounded Time-Series Synthesis</a:t>
+            </a:r>
+          </a:p>
+        </p:txBody>
+      </p:sp>
+      <p:sp>
+        <p:nvSpPr>
+          <p:cNvPr id="5" name="Rounded Rectangle 4"/>
+          <p:cNvSpPr/>
+          <p:nvPr/>
+        </p:nvSpPr>
+        <p:spPr>
+          <a:xfrm>
+            <a:off x="731520" y="2011680"/>
+            <a:ext cx="10698480" cy="4114800"/>
+          </a:xfrm>
+          <a:prstGeom prst="roundRect">
+            <a:avLst/>
+          </a:prstGeom>
+          <a:solidFill>
+            <a:srgbClr val="F8FAFC"/>
+          </a:solidFill>
+          <a:ln w="12700">
+            <a:solidFill>
+              <a:srgbClr val="CBD5E1"/>
+            </a:solidFill>
+          </a:ln>
+        </p:spPr>
+        <p:style>
+          <a:lnRef idx="1">
+            <a:schemeClr val="accent1"/>
+          </a:lnRef>
+          <a:fillRef idx="3">
+            <a:schemeClr val="accent1"/>
+          </a:fillRef>
+          <a:effectRef idx="2">
+            <a:schemeClr val="accent1"/>
+          </a:effectRef>
+          <a:fontRef idx="minor">
+            <a:schemeClr val="lt1"/>
+          </a:fontRef>
+        </p:style>
+        <p:txBody>
+          <a:bodyPr rtlCol="0" anchor="ctr"/>
+          <a:lstStyle/>
+          <a:p>
+            <a:pPr algn="ctr"/>
+          </a:p>
+        </p:txBody>
+      </p:sp>
+      <p:sp>
+        <p:nvSpPr>
+          <p:cNvPr id="6" name="TextBox 5"/>
+          <p:cNvSpPr txBox="1"/>
+          <p:nvPr/>
+        </p:nvSpPr>
+        <p:spPr>
+          <a:xfrm>
+            <a:off x="1005840" y="2286000"/>
+            <a:ext cx="10149840" cy="3657600"/>
+          </a:xfrm>
+          <a:prstGeom prst="rect">
+            <a:avLst/>
+          </a:prstGeom>
+          <a:noFill/>
+        </p:spPr>
+        <p:txBody>
+          <a:bodyPr wrap="square">
+            <a:spAutoFit/>
+          </a:bodyPr>
+          <a:lstStyle/>
+          <a:p>
+            <a:pPr>
+              <a:spcAft>
+                <a:spcPts val="1400"/>
+              </a:spcAft>
+              <a:defRPr sz="1400">
+                <a:solidFill>
+                  <a:srgbClr val="1E293B"/>
+                </a:solidFill>
+                <a:latin typeface="Arial"/>
+              </a:defRPr>
+            </a:pPr>
+            <a:r>
+              <a:t>•  Sampling Frequency: Exactly 5-minute ticks across 5,500 sequential observations (multi-week synthetic trial).</a:t>
+            </a:r>
+          </a:p>
+          <a:p>
+            <a:pPr>
+              <a:spcAft>
+                <a:spcPts val="1400"/>
+              </a:spcAft>
+              <a:defRPr sz="1400">
+                <a:solidFill>
+                  <a:srgbClr val="1E293B"/>
+                </a:solidFill>
+                <a:latin typeface="Arial"/>
+              </a:defRPr>
+            </a:pPr>
+            <a:r>
+              <a:t>•  Gastric Emptying Delay: Exponential convolution of meal carbohydrate events simulating gradual digestive absorption.</a:t>
+            </a:r>
+          </a:p>
+          <a:p>
+            <a:pPr>
+              <a:spcAft>
+                <a:spcPts val="1400"/>
+              </a:spcAft>
+              <a:defRPr sz="1400">
+                <a:solidFill>
+                  <a:srgbClr val="1E293B"/>
+                </a:solidFill>
+                <a:latin typeface="Arial"/>
+              </a:defRPr>
+            </a:pPr>
+            <a:r>
+              <a:t>•  Activity &amp; Uptake: Physical exertion modulates insulin sensitivity and accelerates muscular glucose uptake.</a:t>
+            </a:r>
+          </a:p>
+          <a:p>
+            <a:pPr>
+              <a:spcAft>
+                <a:spcPts val="1400"/>
+              </a:spcAft>
+              <a:defRPr sz="1400">
+                <a:solidFill>
+                  <a:srgbClr val="1E293B"/>
+                </a:solidFill>
+                <a:latin typeface="Arial"/>
+              </a:defRPr>
+            </a:pPr>
+            <a:r>
+              <a:t>•  Heart Rate &amp; Circadian Dynamics: Correlated cardiovascular response and sinusoidal diurnal baseline shifts.</a:t>
+            </a:r>
+          </a:p>
+        </p:txBody>
+      </p:sp>
+      <p:sp>
+        <p:nvSpPr>
+          <p:cNvPr id="7" name="TextBox 6"/>
+          <p:cNvSpPr txBox="1"/>
+          <p:nvPr/>
+        </p:nvSpPr>
+        <p:spPr>
+          <a:xfrm>
+            <a:off x="731520" y="6309360"/>
+            <a:ext cx="10698480" cy="365760"/>
+          </a:xfrm>
+          <a:prstGeom prst="rect">
+            <a:avLst/>
+          </a:prstGeom>
+          <a:noFill/>
+        </p:spPr>
+        <p:txBody>
+          <a:bodyPr wrap="none">
+            <a:spAutoFit/>
+          </a:bodyPr>
+          <a:lstStyle/>
+          <a:p>
+            <a:pPr>
+              <a:defRPr sz="900">
+                <a:solidFill>
+                  <a:srgbClr val="94A3B8"/>
+                </a:solidFill>
+                <a:latin typeface="Arial"/>
+              </a:defRPr>
+            </a:pPr>
+            <a:r>
+              <a:t>Educational Prototype • Not a Medical Device • MIT License • https://github.com/tharundev-123/GlucoTwin_AI</a:t>
             </a:r>
           </a:p>
         </p:txBody>
@@ -3611,69 +5157,276 @@
       <p:grpSpPr/>
       <p:sp>
         <p:nvSpPr>
-          <p:cNvPr id="2" name="Title 1"/>
-          <p:cNvSpPr>
-            <a:spLocks noGrp="1"/>
-          </p:cNvSpPr>
-          <p:nvPr>
-            <p:ph type="title"/>
-          </p:nvPr>
-        </p:nvSpPr>
-        <p:spPr/>
-        <p:txBody>
-          <a:bodyPr/>
-          <a:lstStyle/>
-          <a:p>
-            <a:r>
-              <a:t>Evaluation &amp; Limitations</a:t>
-            </a:r>
-          </a:p>
-        </p:txBody>
-      </p:sp>
-      <p:sp>
-        <p:nvSpPr>
-          <p:cNvPr id="3" name="Content Placeholder 2"/>
-          <p:cNvSpPr>
-            <a:spLocks noGrp="1"/>
-          </p:cNvSpPr>
-          <p:nvPr>
-            <p:ph idx="1"/>
-          </p:nvPr>
-        </p:nvSpPr>
-        <p:spPr/>
-        <p:txBody>
-          <a:bodyPr/>
-          <a:lstStyle/>
-          <a:p>
-            <a:pPr>
-              <a:defRPr sz="2200"/>
-            </a:pPr>
-            <a:r>
-              <a:t>Evaluated MAE: 6.33 mg/dL | RMSE: 7.81 mg/dL (on 698 chronological test samples)</a:t>
-            </a:r>
-          </a:p>
-          <a:p>
-            <a:pPr>
-              <a:defRPr sz="2200"/>
-            </a:pPr>
-            <a:r>
-              <a:t>Synthetic data may not represent real physiology.</a:t>
-            </a:r>
-          </a:p>
-          <a:p>
-            <a:pPr>
-              <a:defRPr sz="2200"/>
-            </a:pPr>
-            <a:r>
-              <a:t>No diagnosis, treatment recommendations or emergency assessment.</a:t>
-            </a:r>
-          </a:p>
-          <a:p>
-            <a:pPr>
-              <a:defRPr sz="2200"/>
-            </a:pPr>
-            <a:r>
-              <a:t>Future work: permitted real-world dataset, calibration, uncertainty and expert review.</a:t>
+          <p:cNvPr id="2" name="TextBox 1"/>
+          <p:cNvSpPr txBox="1"/>
+          <p:nvPr/>
+        </p:nvSpPr>
+        <p:spPr>
+          <a:xfrm>
+            <a:off x="731520" y="457200"/>
+            <a:ext cx="10698480" cy="365760"/>
+          </a:xfrm>
+          <a:prstGeom prst="rect">
+            <a:avLst/>
+          </a:prstGeom>
+          <a:noFill/>
+        </p:spPr>
+        <p:txBody>
+          <a:bodyPr wrap="square">
+            <a:spAutoFit/>
+          </a:bodyPr>
+          <a:lstStyle/>
+          <a:p>
+            <a:pPr>
+              <a:defRPr sz="1100" b="1">
+                <a:solidFill>
+                  <a:srgbClr val="0284C7"/>
+                </a:solidFill>
+                <a:latin typeface="Arial"/>
+              </a:defRPr>
+            </a:pPr>
+            <a:r>
+              <a:t>SLIDE 07/10 • GLUCOTWIN AI — UNSTOP DIGITAL TWIN CHALLENGE 2026</a:t>
+            </a:r>
+          </a:p>
+        </p:txBody>
+      </p:sp>
+      <p:sp>
+        <p:nvSpPr>
+          <p:cNvPr id="3" name="TextBox 2"/>
+          <p:cNvSpPr txBox="1"/>
+          <p:nvPr/>
+        </p:nvSpPr>
+        <p:spPr>
+          <a:xfrm>
+            <a:off x="731520" y="822960"/>
+            <a:ext cx="10698480" cy="640080"/>
+          </a:xfrm>
+          <a:prstGeom prst="rect">
+            <a:avLst/>
+          </a:prstGeom>
+          <a:noFill/>
+        </p:spPr>
+        <p:txBody>
+          <a:bodyPr wrap="square">
+            <a:spAutoFit/>
+          </a:bodyPr>
+          <a:lstStyle/>
+          <a:p>
+            <a:pPr>
+              <a:defRPr sz="2200" b="1">
+                <a:solidFill>
+                  <a:srgbClr val="0C4A6E"/>
+                </a:solidFill>
+                <a:latin typeface="Arial"/>
+              </a:defRPr>
+            </a:pPr>
+            <a:r>
+              <a:t>Feature Engineering &amp; Zero Data Leakage Guarantee</a:t>
+            </a:r>
+          </a:p>
+        </p:txBody>
+      </p:sp>
+      <p:sp>
+        <p:nvSpPr>
+          <p:cNvPr id="4" name="TextBox 3"/>
+          <p:cNvSpPr txBox="1"/>
+          <p:nvPr/>
+        </p:nvSpPr>
+        <p:spPr>
+          <a:xfrm>
+            <a:off x="731520" y="1463040"/>
+            <a:ext cx="10698480" cy="365760"/>
+          </a:xfrm>
+          <a:prstGeom prst="rect">
+            <a:avLst/>
+          </a:prstGeom>
+          <a:noFill/>
+        </p:spPr>
+        <p:txBody>
+          <a:bodyPr wrap="square">
+            <a:spAutoFit/>
+          </a:bodyPr>
+          <a:lstStyle/>
+          <a:p>
+            <a:pPr>
+              <a:defRPr sz="1300">
+                <a:solidFill>
+                  <a:srgbClr val="64748B"/>
+                </a:solidFill>
+                <a:latin typeface="Arial"/>
+              </a:defRPr>
+            </a:pPr>
+            <a:r>
+              <a:t>Rigorous Time-Series Feature Construction</a:t>
+            </a:r>
+          </a:p>
+        </p:txBody>
+      </p:sp>
+      <p:sp>
+        <p:nvSpPr>
+          <p:cNvPr id="5" name="Rounded Rectangle 4"/>
+          <p:cNvSpPr/>
+          <p:nvPr/>
+        </p:nvSpPr>
+        <p:spPr>
+          <a:xfrm>
+            <a:off x="731520" y="2011680"/>
+            <a:ext cx="10698480" cy="4114800"/>
+          </a:xfrm>
+          <a:prstGeom prst="roundRect">
+            <a:avLst/>
+          </a:prstGeom>
+          <a:solidFill>
+            <a:srgbClr val="F8FAFC"/>
+          </a:solidFill>
+          <a:ln w="12700">
+            <a:solidFill>
+              <a:srgbClr val="CBD5E1"/>
+            </a:solidFill>
+          </a:ln>
+        </p:spPr>
+        <p:style>
+          <a:lnRef idx="1">
+            <a:schemeClr val="accent1"/>
+          </a:lnRef>
+          <a:fillRef idx="3">
+            <a:schemeClr val="accent1"/>
+          </a:fillRef>
+          <a:effectRef idx="2">
+            <a:schemeClr val="accent1"/>
+          </a:effectRef>
+          <a:fontRef idx="minor">
+            <a:schemeClr val="lt1"/>
+          </a:fontRef>
+        </p:style>
+        <p:txBody>
+          <a:bodyPr rtlCol="0" anchor="ctr"/>
+          <a:lstStyle/>
+          <a:p>
+            <a:pPr algn="ctr"/>
+          </a:p>
+        </p:txBody>
+      </p:sp>
+      <p:sp>
+        <p:nvSpPr>
+          <p:cNvPr id="6" name="TextBox 5"/>
+          <p:cNvSpPr txBox="1"/>
+          <p:nvPr/>
+        </p:nvSpPr>
+        <p:spPr>
+          <a:xfrm>
+            <a:off x="1005840" y="2286000"/>
+            <a:ext cx="10149840" cy="3657600"/>
+          </a:xfrm>
+          <a:prstGeom prst="rect">
+            <a:avLst/>
+          </a:prstGeom>
+          <a:noFill/>
+        </p:spPr>
+        <p:txBody>
+          <a:bodyPr wrap="square">
+            <a:spAutoFit/>
+          </a:bodyPr>
+          <a:lstStyle/>
+          <a:p>
+            <a:pPr>
+              <a:spcAft>
+                <a:spcPts val="1400"/>
+              </a:spcAft>
+              <a:defRPr sz="1400">
+                <a:solidFill>
+                  <a:srgbClr val="1E293B"/>
+                </a:solidFill>
+                <a:latin typeface="Arial"/>
+              </a:defRPr>
+            </a:pPr>
+            <a:r>
+              <a:t>•  Chronological Sequence: Temporal sorting enforced; past observations strictly segregated from future targets.</a:t>
+            </a:r>
+          </a:p>
+          <a:p>
+            <a:pPr>
+              <a:spcAft>
+                <a:spcPts val="1400"/>
+              </a:spcAft>
+              <a:defRPr sz="1400">
+                <a:solidFill>
+                  <a:srgbClr val="1E293B"/>
+                </a:solidFill>
+                <a:latin typeface="Arial"/>
+              </a:defRPr>
+            </a:pPr>
+            <a:r>
+              <a:t>•  Lag Operators: Lag 1 (5m), Lag 2 (10m), Lag 3 (15m), Lag 6 (30m), Lag 12 (1h), and Lag 24 (2h).</a:t>
+            </a:r>
+          </a:p>
+          <a:p>
+            <a:pPr>
+              <a:spcAft>
+                <a:spcPts val="1400"/>
+              </a:spcAft>
+              <a:defRPr sz="1400">
+                <a:solidFill>
+                  <a:srgbClr val="1E293B"/>
+                </a:solidFill>
+                <a:latin typeface="Arial"/>
+              </a:defRPr>
+            </a:pPr>
+            <a:r>
+              <a:t>•  First Derivatives: Glycemic velocity calculated over 15-minute and 30-minute backward intervals (mg/dL/min).</a:t>
+            </a:r>
+          </a:p>
+          <a:p>
+            <a:pPr>
+              <a:spcAft>
+                <a:spcPts val="1400"/>
+              </a:spcAft>
+              <a:defRPr sz="1400">
+                <a:solidFill>
+                  <a:srgbClr val="1E293B"/>
+                </a:solidFill>
+                <a:latin typeface="Arial"/>
+              </a:defRPr>
+            </a:pPr>
+            <a:r>
+              <a:t>•  Cyclical Harmonic Encoding: Sine and cosine hour representations preserve continuity across midnight boundary.</a:t>
+            </a:r>
+          </a:p>
+        </p:txBody>
+      </p:sp>
+      <p:sp>
+        <p:nvSpPr>
+          <p:cNvPr id="7" name="TextBox 6"/>
+          <p:cNvSpPr txBox="1"/>
+          <p:nvPr/>
+        </p:nvSpPr>
+        <p:spPr>
+          <a:xfrm>
+            <a:off x="731520" y="6309360"/>
+            <a:ext cx="10698480" cy="365760"/>
+          </a:xfrm>
+          <a:prstGeom prst="rect">
+            <a:avLst/>
+          </a:prstGeom>
+          <a:noFill/>
+        </p:spPr>
+        <p:txBody>
+          <a:bodyPr wrap="none">
+            <a:spAutoFit/>
+          </a:bodyPr>
+          <a:lstStyle/>
+          <a:p>
+            <a:pPr>
+              <a:defRPr sz="900">
+                <a:solidFill>
+                  <a:srgbClr val="94A3B8"/>
+                </a:solidFill>
+                <a:latin typeface="Arial"/>
+              </a:defRPr>
+            </a:pPr>
+            <a:r>
+              <a:t>Educational Prototype • Not a Medical Device • MIT License • https://github.com/tharundev-123/GlucoTwin_AI</a:t>
             </a:r>
           </a:p>
         </p:txBody>
@@ -3698,69 +5451,570 @@
       <p:grpSpPr/>
       <p:sp>
         <p:nvSpPr>
-          <p:cNvPr id="2" name="Title 1"/>
-          <p:cNvSpPr>
-            <a:spLocks noGrp="1"/>
-          </p:cNvSpPr>
-          <p:nvPr>
-            <p:ph type="title"/>
-          </p:nvPr>
-        </p:nvSpPr>
-        <p:spPr/>
-        <p:txBody>
-          <a:bodyPr/>
-          <a:lstStyle/>
-          <a:p>
-            <a:r>
-              <a:t>Open Source &amp; Demo</a:t>
-            </a:r>
-          </a:p>
-        </p:txBody>
-      </p:sp>
-      <p:sp>
-        <p:nvSpPr>
-          <p:cNvPr id="3" name="Content Placeholder 2"/>
-          <p:cNvSpPr>
-            <a:spLocks noGrp="1"/>
-          </p:cNvSpPr>
-          <p:nvPr>
-            <p:ph idx="1"/>
-          </p:nvPr>
-        </p:nvSpPr>
-        <p:spPr/>
-        <p:txBody>
-          <a:bodyPr/>
-          <a:lstStyle/>
-          <a:p>
-            <a:pPr>
-              <a:defRPr sz="2200"/>
-            </a:pPr>
-            <a:r>
-              <a:t>Licence: MIT</a:t>
-            </a:r>
-          </a:p>
-          <a:p>
-            <a:pPr>
-              <a:defRPr sz="2200"/>
-            </a:pPr>
-            <a:r>
-              <a:t>Public GitHub: https://github.com/tharundev-123/GlucoTwin_AI</a:t>
-            </a:r>
-          </a:p>
-          <a:p>
-            <a:pPr>
-              <a:defRPr sz="2200"/>
-            </a:pPr>
-            <a:r>
-              <a:t>Add unlisted 15–20 minute YouTube demo link to README</a:t>
-            </a:r>
-          </a:p>
-          <a:p>
-            <a:pPr>
-              <a:defRPr sz="2200"/>
-            </a:pPr>
-            <a:r>
-              <a:t>Complete ready-to-run package with 3D web dashboard &amp; verified benchmarks</a:t>
+          <p:cNvPr id="2" name="TextBox 1"/>
+          <p:cNvSpPr txBox="1"/>
+          <p:nvPr/>
+        </p:nvSpPr>
+        <p:spPr>
+          <a:xfrm>
+            <a:off x="731520" y="457200"/>
+            <a:ext cx="10698480" cy="365760"/>
+          </a:xfrm>
+          <a:prstGeom prst="rect">
+            <a:avLst/>
+          </a:prstGeom>
+          <a:noFill/>
+        </p:spPr>
+        <p:txBody>
+          <a:bodyPr wrap="square">
+            <a:spAutoFit/>
+          </a:bodyPr>
+          <a:lstStyle/>
+          <a:p>
+            <a:pPr>
+              <a:defRPr sz="1100" b="1">
+                <a:solidFill>
+                  <a:srgbClr val="0284C7"/>
+                </a:solidFill>
+                <a:latin typeface="Arial"/>
+              </a:defRPr>
+            </a:pPr>
+            <a:r>
+              <a:t>SLIDE 08/10 • GLUCOTWIN AI — UNSTOP DIGITAL TWIN CHALLENGE 2026</a:t>
+            </a:r>
+          </a:p>
+        </p:txBody>
+      </p:sp>
+      <p:sp>
+        <p:nvSpPr>
+          <p:cNvPr id="3" name="TextBox 2"/>
+          <p:cNvSpPr txBox="1"/>
+          <p:nvPr/>
+        </p:nvSpPr>
+        <p:spPr>
+          <a:xfrm>
+            <a:off x="731520" y="822960"/>
+            <a:ext cx="10698480" cy="640080"/>
+          </a:xfrm>
+          <a:prstGeom prst="rect">
+            <a:avLst/>
+          </a:prstGeom>
+          <a:noFill/>
+        </p:spPr>
+        <p:txBody>
+          <a:bodyPr wrap="square">
+            <a:spAutoFit/>
+          </a:bodyPr>
+          <a:lstStyle/>
+          <a:p>
+            <a:pPr>
+              <a:defRPr sz="2200" b="1">
+                <a:solidFill>
+                  <a:srgbClr val="0C4A6E"/>
+                </a:solidFill>
+                <a:latin typeface="Arial"/>
+              </a:defRPr>
+            </a:pPr>
+            <a:r>
+              <a:t>Machine Learning Ensemble &amp; Uncertainty Quantification</a:t>
+            </a:r>
+          </a:p>
+        </p:txBody>
+      </p:sp>
+      <p:sp>
+        <p:nvSpPr>
+          <p:cNvPr id="4" name="TextBox 3"/>
+          <p:cNvSpPr txBox="1"/>
+          <p:nvPr/>
+        </p:nvSpPr>
+        <p:spPr>
+          <a:xfrm>
+            <a:off x="731520" y="1463040"/>
+            <a:ext cx="10698480" cy="365760"/>
+          </a:xfrm>
+          <a:prstGeom prst="rect">
+            <a:avLst/>
+          </a:prstGeom>
+          <a:noFill/>
+        </p:spPr>
+        <p:txBody>
+          <a:bodyPr wrap="square">
+            <a:spAutoFit/>
+          </a:bodyPr>
+          <a:lstStyle/>
+          <a:p>
+            <a:pPr>
+              <a:defRPr sz="1300">
+                <a:solidFill>
+                  <a:srgbClr val="64748B"/>
+                </a:solidFill>
+                <a:latin typeface="Arial"/>
+              </a:defRPr>
+            </a:pPr>
+            <a:r>
+              <a:t>Ensemble Variance for Defensible Confidence Intervals</a:t>
+            </a:r>
+          </a:p>
+        </p:txBody>
+      </p:sp>
+      <p:sp>
+        <p:nvSpPr>
+          <p:cNvPr id="5" name="Rounded Rectangle 4"/>
+          <p:cNvSpPr/>
+          <p:nvPr/>
+        </p:nvSpPr>
+        <p:spPr>
+          <a:xfrm>
+            <a:off x="731520" y="2011680"/>
+            <a:ext cx="10698480" cy="4114800"/>
+          </a:xfrm>
+          <a:prstGeom prst="roundRect">
+            <a:avLst/>
+          </a:prstGeom>
+          <a:solidFill>
+            <a:srgbClr val="F8FAFC"/>
+          </a:solidFill>
+          <a:ln w="12700">
+            <a:solidFill>
+              <a:srgbClr val="CBD5E1"/>
+            </a:solidFill>
+          </a:ln>
+        </p:spPr>
+        <p:style>
+          <a:lnRef idx="1">
+            <a:schemeClr val="accent1"/>
+          </a:lnRef>
+          <a:fillRef idx="3">
+            <a:schemeClr val="accent1"/>
+          </a:fillRef>
+          <a:effectRef idx="2">
+            <a:schemeClr val="accent1"/>
+          </a:effectRef>
+          <a:fontRef idx="minor">
+            <a:schemeClr val="lt1"/>
+          </a:fontRef>
+        </p:style>
+        <p:txBody>
+          <a:bodyPr rtlCol="0" anchor="ctr"/>
+          <a:lstStyle/>
+          <a:p>
+            <a:pPr algn="ctr"/>
+          </a:p>
+        </p:txBody>
+      </p:sp>
+      <p:sp>
+        <p:nvSpPr>
+          <p:cNvPr id="6" name="TextBox 5"/>
+          <p:cNvSpPr txBox="1"/>
+          <p:nvPr/>
+        </p:nvSpPr>
+        <p:spPr>
+          <a:xfrm>
+            <a:off x="1005840" y="2286000"/>
+            <a:ext cx="10149840" cy="3657600"/>
+          </a:xfrm>
+          <a:prstGeom prst="rect">
+            <a:avLst/>
+          </a:prstGeom>
+          <a:noFill/>
+        </p:spPr>
+        <p:txBody>
+          <a:bodyPr wrap="square">
+            <a:spAutoFit/>
+          </a:bodyPr>
+          <a:lstStyle/>
+          <a:p>
+            <a:pPr>
+              <a:spcAft>
+                <a:spcPts val="1400"/>
+              </a:spcAft>
+              <a:defRPr sz="1400">
+                <a:solidFill>
+                  <a:srgbClr val="1E293B"/>
+                </a:solidFill>
+                <a:latin typeface="Arial"/>
+              </a:defRPr>
+            </a:pPr>
+            <a:r>
+              <a:t>•  Model Architecture: RandomForestRegressor (150 estimators, max_depth=14, min_samples_split=4).</a:t>
+            </a:r>
+          </a:p>
+          <a:p>
+            <a:pPr>
+              <a:spcAft>
+                <a:spcPts val="1400"/>
+              </a:spcAft>
+              <a:defRPr sz="1400">
+                <a:solidFill>
+                  <a:srgbClr val="1E293B"/>
+                </a:solidFill>
+                <a:latin typeface="Arial"/>
+              </a:defRPr>
+            </a:pPr>
+            <a:r>
+              <a:t>•  2-Hour Target Formulation: Precisely y(t+24), forecasting glucose exactly 120 minutes ahead.</a:t>
+            </a:r>
+          </a:p>
+          <a:p>
+            <a:pPr>
+              <a:spcAft>
+                <a:spcPts val="1400"/>
+              </a:spcAft>
+              <a:defRPr sz="1400">
+                <a:solidFill>
+                  <a:srgbClr val="1E293B"/>
+                </a:solidFill>
+                <a:latin typeface="Arial"/>
+              </a:defRPr>
+            </a:pPr>
+            <a:r>
+              <a:t>•  Defensible Uncertainty: Computes empirical variance across all 150 individual decision tree estimates.</a:t>
+            </a:r>
+          </a:p>
+          <a:p>
+            <a:pPr>
+              <a:spcAft>
+                <a:spcPts val="1400"/>
+              </a:spcAft>
+              <a:defRPr sz="1400">
+                <a:solidFill>
+                  <a:srgbClr val="1E293B"/>
+                </a:solidFill>
+                <a:latin typeface="Arial"/>
+              </a:defRPr>
+            </a:pPr>
+            <a:r>
+              <a:t>•  95% Prediction Interval: [y_hat - 1.96*sigma, y_hat + 1.96*sigma] dynamically rendered on telemetry charts.</a:t>
+            </a:r>
+          </a:p>
+        </p:txBody>
+      </p:sp>
+      <p:sp>
+        <p:nvSpPr>
+          <p:cNvPr id="7" name="TextBox 6"/>
+          <p:cNvSpPr txBox="1"/>
+          <p:nvPr/>
+        </p:nvSpPr>
+        <p:spPr>
+          <a:xfrm>
+            <a:off x="731520" y="6309360"/>
+            <a:ext cx="10698480" cy="365760"/>
+          </a:xfrm>
+          <a:prstGeom prst="rect">
+            <a:avLst/>
+          </a:prstGeom>
+          <a:noFill/>
+        </p:spPr>
+        <p:txBody>
+          <a:bodyPr wrap="none">
+            <a:spAutoFit/>
+          </a:bodyPr>
+          <a:lstStyle/>
+          <a:p>
+            <a:pPr>
+              <a:defRPr sz="900">
+                <a:solidFill>
+                  <a:srgbClr val="94A3B8"/>
+                </a:solidFill>
+                <a:latin typeface="Arial"/>
+              </a:defRPr>
+            </a:pPr>
+            <a:r>
+              <a:t>Educational Prototype • Not a Medical Device • MIT License • https://github.com/tharundev-123/GlucoTwin_AI</a:t>
+            </a:r>
+          </a:p>
+        </p:txBody>
+      </p:sp>
+    </p:spTree>
+  </p:cSld>
+  <p:clrMapOvr>
+    <a:masterClrMapping/>
+  </p:clrMapOvr>
+</p:sld>
+</file>
+
+<file path=ppt/slides/slide9.xml><?xml version="1.0" encoding="utf-8"?>
+<p:sld xmlns:a="http://schemas.openxmlformats.org/drawingml/2006/main" xmlns:p="http://schemas.openxmlformats.org/presentationml/2006/main" xmlns:r="http://schemas.openxmlformats.org/officeDocument/2006/relationships">
+  <p:cSld>
+    <p:spTree>
+      <p:nvGrpSpPr>
+        <p:cNvPr id="1" name=""/>
+        <p:cNvGrpSpPr/>
+        <p:nvPr/>
+      </p:nvGrpSpPr>
+      <p:grpSpPr/>
+      <p:sp>
+        <p:nvSpPr>
+          <p:cNvPr id="2" name="TextBox 1"/>
+          <p:cNvSpPr txBox="1"/>
+          <p:nvPr/>
+        </p:nvSpPr>
+        <p:spPr>
+          <a:xfrm>
+            <a:off x="731520" y="457200"/>
+            <a:ext cx="10698480" cy="365760"/>
+          </a:xfrm>
+          <a:prstGeom prst="rect">
+            <a:avLst/>
+          </a:prstGeom>
+          <a:noFill/>
+        </p:spPr>
+        <p:txBody>
+          <a:bodyPr wrap="square">
+            <a:spAutoFit/>
+          </a:bodyPr>
+          <a:lstStyle/>
+          <a:p>
+            <a:pPr>
+              <a:defRPr sz="1100" b="1">
+                <a:solidFill>
+                  <a:srgbClr val="0284C7"/>
+                </a:solidFill>
+                <a:latin typeface="Arial"/>
+              </a:defRPr>
+            </a:pPr>
+            <a:r>
+              <a:t>SLIDE 09/10 • GLUCOTWIN AI — UNSTOP DIGITAL TWIN CHALLENGE 2026</a:t>
+            </a:r>
+          </a:p>
+        </p:txBody>
+      </p:sp>
+      <p:sp>
+        <p:nvSpPr>
+          <p:cNvPr id="3" name="TextBox 2"/>
+          <p:cNvSpPr txBox="1"/>
+          <p:nvPr/>
+        </p:nvSpPr>
+        <p:spPr>
+          <a:xfrm>
+            <a:off x="731520" y="822960"/>
+            <a:ext cx="10698480" cy="640080"/>
+          </a:xfrm>
+          <a:prstGeom prst="rect">
+            <a:avLst/>
+          </a:prstGeom>
+          <a:noFill/>
+        </p:spPr>
+        <p:txBody>
+          <a:bodyPr wrap="square">
+            <a:spAutoFit/>
+          </a:bodyPr>
+          <a:lstStyle/>
+          <a:p>
+            <a:pPr>
+              <a:defRPr sz="2200" b="1">
+                <a:solidFill>
+                  <a:srgbClr val="0C4A6E"/>
+                </a:solidFill>
+                <a:latin typeface="Arial"/>
+              </a:defRPr>
+            </a:pPr>
+            <a:r>
+              <a:t>Empirical Evaluation vs. Persistence Baseline</a:t>
+            </a:r>
+          </a:p>
+        </p:txBody>
+      </p:sp>
+      <p:sp>
+        <p:nvSpPr>
+          <p:cNvPr id="4" name="TextBox 3"/>
+          <p:cNvSpPr txBox="1"/>
+          <p:nvPr/>
+        </p:nvSpPr>
+        <p:spPr>
+          <a:xfrm>
+            <a:off x="731520" y="1463040"/>
+            <a:ext cx="10698480" cy="365760"/>
+          </a:xfrm>
+          <a:prstGeom prst="rect">
+            <a:avLst/>
+          </a:prstGeom>
+          <a:noFill/>
+        </p:spPr>
+        <p:txBody>
+          <a:bodyPr wrap="square">
+            <a:spAutoFit/>
+          </a:bodyPr>
+          <a:lstStyle/>
+          <a:p>
+            <a:pPr>
+              <a:defRPr sz="1300">
+                <a:solidFill>
+                  <a:srgbClr val="64748B"/>
+                </a:solidFill>
+                <a:latin typeface="Arial"/>
+              </a:defRPr>
+            </a:pPr>
+            <a:r>
+              <a:t>Honest Metric Reporting on 1,091 Chronological Test Samples</a:t>
+            </a:r>
+          </a:p>
+        </p:txBody>
+      </p:sp>
+      <p:sp>
+        <p:nvSpPr>
+          <p:cNvPr id="5" name="Rounded Rectangle 4"/>
+          <p:cNvSpPr/>
+          <p:nvPr/>
+        </p:nvSpPr>
+        <p:spPr>
+          <a:xfrm>
+            <a:off x="731520" y="2011680"/>
+            <a:ext cx="10698480" cy="4114800"/>
+          </a:xfrm>
+          <a:prstGeom prst="roundRect">
+            <a:avLst/>
+          </a:prstGeom>
+          <a:solidFill>
+            <a:srgbClr val="F8FAFC"/>
+          </a:solidFill>
+          <a:ln w="12700">
+            <a:solidFill>
+              <a:srgbClr val="CBD5E1"/>
+            </a:solidFill>
+          </a:ln>
+        </p:spPr>
+        <p:style>
+          <a:lnRef idx="1">
+            <a:schemeClr val="accent1"/>
+          </a:lnRef>
+          <a:fillRef idx="3">
+            <a:schemeClr val="accent1"/>
+          </a:fillRef>
+          <a:effectRef idx="2">
+            <a:schemeClr val="accent1"/>
+          </a:effectRef>
+          <a:fontRef idx="minor">
+            <a:schemeClr val="lt1"/>
+          </a:fontRef>
+        </p:style>
+        <p:txBody>
+          <a:bodyPr rtlCol="0" anchor="ctr"/>
+          <a:lstStyle/>
+          <a:p>
+            <a:pPr algn="ctr"/>
+          </a:p>
+        </p:txBody>
+      </p:sp>
+      <p:sp>
+        <p:nvSpPr>
+          <p:cNvPr id="6" name="TextBox 5"/>
+          <p:cNvSpPr txBox="1"/>
+          <p:nvPr/>
+        </p:nvSpPr>
+        <p:spPr>
+          <a:xfrm>
+            <a:off x="1005840" y="2286000"/>
+            <a:ext cx="10149840" cy="3657600"/>
+          </a:xfrm>
+          <a:prstGeom prst="rect">
+            <a:avLst/>
+          </a:prstGeom>
+          <a:noFill/>
+        </p:spPr>
+        <p:txBody>
+          <a:bodyPr wrap="square">
+            <a:spAutoFit/>
+          </a:bodyPr>
+          <a:lstStyle/>
+          <a:p>
+            <a:pPr>
+              <a:spcAft>
+                <a:spcPts val="1400"/>
+              </a:spcAft>
+              <a:defRPr sz="1400">
+                <a:solidFill>
+                  <a:srgbClr val="1E293B"/>
+                </a:solidFill>
+                <a:latin typeface="Arial"/>
+              </a:defRPr>
+            </a:pPr>
+            <a:r>
+              <a:t>•  Trained Model MAE: 5.260 mg/dL (vs. Persistence: 48.711 mg/dL — +89.2% improvement).</a:t>
+            </a:r>
+          </a:p>
+          <a:p>
+            <a:pPr>
+              <a:spcAft>
+                <a:spcPts val="1400"/>
+              </a:spcAft>
+              <a:defRPr sz="1400">
+                <a:solidFill>
+                  <a:srgbClr val="1E293B"/>
+                </a:solidFill>
+                <a:latin typeface="Arial"/>
+              </a:defRPr>
+            </a:pPr>
+            <a:r>
+              <a:t>•  Trained Model RMSE: 7.160 mg/dL (vs. Persistence: 59.482 mg/dL — +88.0% improvement).</a:t>
+            </a:r>
+          </a:p>
+          <a:p>
+            <a:pPr>
+              <a:spcAft>
+                <a:spcPts val="1400"/>
+              </a:spcAft>
+              <a:defRPr sz="1400">
+                <a:solidFill>
+                  <a:srgbClr val="1E293B"/>
+                </a:solidFill>
+                <a:latin typeface="Arial"/>
+              </a:defRPr>
+            </a:pPr>
+            <a:r>
+              <a:t>•  Why Persistence Fails at 2h: Glycemic states experience substantial movement over 120m due to meals and activity.</a:t>
+            </a:r>
+          </a:p>
+          <a:p>
+            <a:pPr>
+              <a:spcAft>
+                <a:spcPts val="1400"/>
+              </a:spcAft>
+              <a:defRPr sz="1400">
+                <a:solidFill>
+                  <a:srgbClr val="1E293B"/>
+                </a:solidFill>
+                <a:latin typeface="Arial"/>
+              </a:defRPr>
+            </a:pPr>
+            <a:r>
+              <a:t>•  Top Feature Importance: Circadian harmonics (cos_hour: 56.2%), current glucose (11.5%), and lag-1 (8.4%) dominate.</a:t>
+            </a:r>
+          </a:p>
+        </p:txBody>
+      </p:sp>
+      <p:sp>
+        <p:nvSpPr>
+          <p:cNvPr id="7" name="TextBox 6"/>
+          <p:cNvSpPr txBox="1"/>
+          <p:nvPr/>
+        </p:nvSpPr>
+        <p:spPr>
+          <a:xfrm>
+            <a:off x="731520" y="6309360"/>
+            <a:ext cx="10698480" cy="365760"/>
+          </a:xfrm>
+          <a:prstGeom prst="rect">
+            <a:avLst/>
+          </a:prstGeom>
+          <a:noFill/>
+        </p:spPr>
+        <p:txBody>
+          <a:bodyPr wrap="none">
+            <a:spAutoFit/>
+          </a:bodyPr>
+          <a:lstStyle/>
+          <a:p>
+            <a:pPr>
+              <a:defRPr sz="900">
+                <a:solidFill>
+                  <a:srgbClr val="94A3B8"/>
+                </a:solidFill>
+                <a:latin typeface="Arial"/>
+              </a:defRPr>
+            </a:pPr>
+            <a:r>
+              <a:t>Educational Prototype • Not a Medical Device • MIT License • https://github.com/tharundev-123/GlucoTwin_AI</a:t>
             </a:r>
           </a:p>
         </p:txBody>

</xml_diff>

<commit_message>
docs & ui: update team credentials to Team Winners and rebuild distribution
</commit_message>
<xml_diff>
--- a/docs/presentation.pptx
+++ b/docs/presentation.pptx
@@ -3200,7 +3200,7 @@
               </a:defRPr>
             </a:pPr>
             <a:r>
-              <a:t>Unstop Digital Twin Challenge 2026 | Comprehensive Proof of Concept</a:t>
+              <a:t>Team Winners | Chandigarh University, UP | Unstop Digital Twin Challenge 2026</a:t>
             </a:r>
           </a:p>
         </p:txBody>
@@ -3284,7 +3284,7 @@
               </a:defRPr>
             </a:pPr>
             <a:r>
-              <a:t>•  Project Mission: Develop an educational physiological digital twin predicting glucose trends 2 hours ahead.</a:t>
+              <a:t>•  Team Members: Tharun Dev M C (Lead AI/ML), Ashish Kumar Rawat (Full-Stack/Cloud), Saim Quadeer (UI/UX).</a:t>
             </a:r>
           </a:p>
           <a:p>
@@ -3300,7 +3300,7 @@
               </a:defRPr>
             </a:pPr>
             <a:r>
-              <a:t>•  Core Paradigm: Continuously updates virtual patient state using time-series sensor data &amp; contextual events.</a:t>
+              <a:t>•  Department &amp; Degree: Department of Computer Science &amp; Engineering — B.Tech in CSE (AI &amp; ML).</a:t>
             </a:r>
           </a:p>
           <a:p>
@@ -3316,7 +3316,7 @@
               </a:defRPr>
             </a:pPr>
             <a:r>
-              <a:t>•  Honest Science: Compares trained ML models against simple persistence baselines with zero future data leakage.</a:t>
+              <a:t>•  Project Mission: Develop an educational physiological digital twin predicting glucose trends 2 hours ahead.</a:t>
             </a:r>
           </a:p>
           <a:p>
@@ -3332,7 +3332,7 @@
               </a:defRPr>
             </a:pPr>
             <a:r>
-              <a:t>•  Regulatory Status: Purely educational and research demonstration. Not a medical device. Non-diagnostic.</a:t>
+              <a:t>•  Regulatory Status: Purely educational and research demonstration. Not a medical device. Independent Entry.</a:t>
             </a:r>
           </a:p>
         </p:txBody>

</xml_diff>